<commit_message>
Deck: manual partner email on the 'today' BPMN slide, stats slide re-laid out with KPI tiles on top and returned hours below, plus new team and commercial-proposal slides
- Slide 2: 'Auto-notification of partners by email' -> 'Manual email to partners';
  the automated wording stays on the 'with Nexus' slide.
- Slide 4 (stats_v3): four KPI tiles now form a row across the top and the
  158 h/mo hero card spans the full width below them.
- New closing slides: build_author() (founding engineer + team of four,
  optional assets/author.jpg photo) and build_pricing() (5,000,000 KZT phase 1
  on the client's server + optional 5,000,000 KZT phase 2).

Co-Authored-By: Claude <noreply@anthropic.com>
</commit_message>
<xml_diff>
--- a/deck/Efes_Nexus_EN.pptx
+++ b/deck/Efes_Nexus_EN.pptx
@@ -16,6 +16,8 @@
     <p:sldId id="257" r:id="rId4"/>
     <p:sldId id="261" r:id="rId5"/>
     <p:sldId id="264" r:id="rId7"/>
+    <p:sldId id="268" r:id="rId16"/>
+    <p:sldId id="269" r:id="rId17"/>
   </p:sldIdLst>
   <p:sldSz cx="12192000" cy="6858000"/>
   <p:notesSz cx="6858000" cy="12192000"/>
@@ -1777,6 +1779,2837 @@
 </p:sld>
 </file>
 
+<file path=ppt/slides/slide10.xml><?xml version="1.0" encoding="utf-8"?>
+<p:sld xmlns:a="http://schemas.openxmlformats.org/drawingml/2006/main" xmlns:p="http://schemas.openxmlformats.org/presentationml/2006/main" xmlns:r="http://schemas.openxmlformats.org/officeDocument/2006/relationships">
+  <p:cSld>
+    <p:bg>
+      <p:bgPr>
+        <a:solidFill>
+          <a:srgbClr val="F6F8FA"/>
+        </a:solidFill>
+        <a:effectLst/>
+      </p:bgPr>
+    </p:bg>
+    <p:spTree>
+      <p:nvGrpSpPr>
+        <p:cNvPr id="1" name=""/>
+        <p:cNvGrpSpPr/>
+        <p:nvPr/>
+      </p:nvGrpSpPr>
+      <p:grpSpPr/>
+      <p:sp>
+        <p:nvSpPr>
+          <p:cNvPr id="135" name="Shape 125"/>
+          <p:cNvSpPr/>
+          <p:nvPr/>
+        </p:nvSpPr>
+        <p:spPr>
+          <a:xfrm>
+            <a:off x="566928" y="6364224"/>
+            <a:ext cx="11057839" cy="0"/>
+          </a:xfrm>
+          <a:prstGeom prst="line">
+            <a:avLst/>
+          </a:prstGeom>
+          <a:noFill/>
+          <a:ln w="12700">
+            <a:solidFill>
+              <a:srgbClr val="E2E7EE"/>
+            </a:solidFill>
+            <a:prstDash val="solid"/>
+          </a:ln>
+        </p:spPr>
+        <p:txBody>
+          <a:bodyPr/>
+          <a:lstStyle/>
+          <a:p>
+            <a:endParaRPr lang="en-US"/>
+          </a:p>
+        </p:txBody>
+      </p:sp>
+      <p:pic>
+        <p:nvPicPr>
+          <p:cNvPr id="136" name="Image 8" descr="/Users/asetseksenali/Downloads/efes/assets/efes-badge.png"/>
+          <p:cNvPicPr>
+            <a:picLocks noChangeAspect="1"/>
+          </p:cNvPicPr>
+          <p:nvPr/>
+        </p:nvPicPr>
+        <p:blipFill>
+          <a:blip r:embed="rId3"/>
+          <a:stretch>
+            <a:fillRect/>
+          </a:stretch>
+        </p:blipFill>
+        <p:spPr>
+          <a:xfrm>
+            <a:off x="566928" y="6458620"/>
+            <a:ext cx="219456" cy="176967"/>
+          </a:xfrm>
+          <a:prstGeom prst="rect">
+            <a:avLst/>
+          </a:prstGeom>
+        </p:spPr>
+      </p:pic>
+      <p:sp>
+        <p:nvSpPr>
+          <p:cNvPr id="137" name="Text 126"/>
+          <p:cNvSpPr/>
+          <p:nvPr/>
+        </p:nvSpPr>
+        <p:spPr>
+          <a:xfrm>
+            <a:off x="859536" y="6400800"/>
+            <a:ext cx="4572000" cy="292608"/>
+          </a:xfrm>
+          <a:prstGeom prst="rect">
+            <a:avLst/>
+          </a:prstGeom>
+          <a:noFill/>
+          <a:ln/>
+        </p:spPr>
+        <p:txBody>
+          <a:bodyPr wrap="square" rtlCol="0" anchor="ctr"/>
+          <a:lstStyle/>
+          <a:p>
+            <a:pPr marL="0" indent="0">
+              <a:buNone/>
+            </a:pPr>
+            <a:r>
+              <a:rPr lang="en-US" sz="850" dirty="0">
+                <a:solidFill>
+                  <a:srgbClr val="8B94A2"/>
+                </a:solidFill>
+                <a:latin typeface="Calibri" pitchFamily="34" charset="0"/>
+                <a:ea typeface="Calibri" pitchFamily="34" charset="-122"/>
+                <a:cs typeface="Calibri" pitchFamily="34" charset="-120"/>
+              </a:rPr>
+              <a:t>Efes Kazakhstan</a:t>
+            </a:r>
+            <a:endParaRPr lang="en-US" sz="850" dirty="0"/>
+          </a:p>
+        </p:txBody>
+      </p:sp>
+      <p:sp>
+        <p:nvSpPr>
+          <p:cNvPr id="138" name="Text 127"/>
+          <p:cNvSpPr/>
+          <p:nvPr/>
+        </p:nvSpPr>
+        <p:spPr>
+          <a:xfrm>
+            <a:off x="6858000" y="6400800"/>
+            <a:ext cx="4766767" cy="292608"/>
+          </a:xfrm>
+          <a:prstGeom prst="rect">
+            <a:avLst/>
+          </a:prstGeom>
+          <a:noFill/>
+          <a:ln/>
+        </p:spPr>
+        <p:txBody>
+          <a:bodyPr wrap="square" rtlCol="0" anchor="ctr"/>
+          <a:lstStyle/>
+          <a:p>
+            <a:pPr marL="0" indent="0" algn="r">
+              <a:buNone/>
+            </a:pPr>
+            <a:r>
+              <a:rPr lang="en-US" sz="850" dirty="0">
+                <a:solidFill>
+                  <a:srgbClr val="8B94A2"/>
+                </a:solidFill>
+                <a:latin typeface="Calibri" pitchFamily="34" charset="0"/>
+                <a:ea typeface="Calibri" pitchFamily="34" charset="-122"/>
+                <a:cs typeface="Calibri" pitchFamily="34" charset="-120"/>
+              </a:rPr>
+              <a:t>Efes Nexus</a:t>
+            </a:r>
+            <a:endParaRPr lang="en-US" sz="850" dirty="0"/>
+          </a:p>
+        </p:txBody>
+      </p:sp>
+      <p:sp>
+        <p:nvSpPr>
+          <p:cNvPr id="139" name="Rectangle 138"/>
+          <p:cNvSpPr/>
+          <p:nvPr/>
+        </p:nvSpPr>
+        <p:spPr>
+          <a:xfrm>
+            <a:off x="566928" y="589788"/>
+            <a:ext cx="155448" cy="29260"/>
+          </a:xfrm>
+          <a:prstGeom prst="rect">
+            <a:avLst/>
+          </a:prstGeom>
+          <a:solidFill>
+            <a:srgbClr val="004C8D"/>
+          </a:solidFill>
+          <a:ln>
+            <a:noFill/>
+          </a:ln>
+          <a:effectLst/>
+        </p:spPr>
+        <p:style>
+          <a:lnRef idx="1">
+            <a:schemeClr val="accent1"/>
+          </a:lnRef>
+          <a:fillRef idx="3">
+            <a:schemeClr val="accent1"/>
+          </a:fillRef>
+          <a:effectRef idx="2">
+            <a:schemeClr val="accent1"/>
+          </a:effectRef>
+          <a:fontRef idx="minor">
+            <a:schemeClr val="lt1"/>
+          </a:fontRef>
+        </p:style>
+        <p:txBody>
+          <a:bodyPr rtlCol="0" anchor="ctr"/>
+          <a:lstStyle/>
+          <a:p>
+            <a:pPr algn="ctr"/>
+          </a:p>
+        </p:txBody>
+      </p:sp>
+      <p:sp>
+        <p:nvSpPr>
+          <p:cNvPr id="140" name="TextBox 139"/>
+          <p:cNvSpPr txBox="1"/>
+          <p:nvPr/>
+        </p:nvSpPr>
+        <p:spPr>
+          <a:xfrm>
+            <a:off x="795528" y="466344"/>
+            <a:ext cx="8229600" cy="274320"/>
+          </a:xfrm>
+          <a:prstGeom prst="rect">
+            <a:avLst/>
+          </a:prstGeom>
+          <a:noFill/>
+        </p:spPr>
+        <p:txBody>
+          <a:bodyPr wrap="square" lIns="18288" rIns="18288" tIns="9144" bIns="9144" anchor="ctr">
+            <a:spAutoFit/>
+          </a:bodyPr>
+          <a:lstStyle/>
+          <a:p>
+            <a:pPr algn="l"/>
+            <a:r>
+              <a:rPr sz="1050" b="1" i="0" spc="200">
+                <a:solidFill>
+                  <a:srgbClr val="1166A8"/>
+                </a:solidFill>
+                <a:latin typeface="Calibri"/>
+              </a:rPr>
+              <a:t>THE TEAM</a:t>
+            </a:r>
+          </a:p>
+        </p:txBody>
+      </p:sp>
+      <p:sp>
+        <p:nvSpPr>
+          <p:cNvPr id="141" name="TextBox 140"/>
+          <p:cNvSpPr txBox="1"/>
+          <p:nvPr/>
+        </p:nvSpPr>
+        <p:spPr>
+          <a:xfrm>
+            <a:off x="566928" y="786384"/>
+            <a:ext cx="11057839" cy="603504"/>
+          </a:xfrm>
+          <a:prstGeom prst="rect">
+            <a:avLst/>
+          </a:prstGeom>
+          <a:noFill/>
+        </p:spPr>
+        <p:txBody>
+          <a:bodyPr wrap="square" lIns="18288" rIns="18288" tIns="9144" bIns="9144" anchor="ctr">
+            <a:spAutoFit/>
+          </a:bodyPr>
+          <a:lstStyle/>
+          <a:p>
+            <a:pPr algn="l"/>
+            <a:r>
+              <a:rPr sz="2900" b="1" i="0">
+                <a:solidFill>
+                  <a:srgbClr val="0C1726"/>
+                </a:solidFill>
+                <a:latin typeface="Calibri"/>
+              </a:rPr>
+              <a:t>Who builds Efes Nexus</a:t>
+            </a:r>
+          </a:p>
+        </p:txBody>
+      </p:sp>
+      <p:sp>
+        <p:nvSpPr>
+          <p:cNvPr id="142" name="TextBox 141"/>
+          <p:cNvSpPr txBox="1"/>
+          <p:nvPr/>
+        </p:nvSpPr>
+        <p:spPr>
+          <a:xfrm>
+            <a:off x="566928" y="1426464"/>
+            <a:ext cx="10881360" cy="548640"/>
+          </a:xfrm>
+          <a:prstGeom prst="rect">
+            <a:avLst/>
+          </a:prstGeom>
+          <a:noFill/>
+        </p:spPr>
+        <p:txBody>
+          <a:bodyPr wrap="square" lIns="18288" rIns="18288" tIns="9144" bIns="9144" anchor="t">
+            <a:spAutoFit/>
+          </a:bodyPr>
+          <a:lstStyle/>
+          <a:p>
+            <a:pPr algn="l">
+              <a:lnSpc>
+                <a:spcPct val="115000"/>
+              </a:lnSpc>
+            </a:pPr>
+            <a:r>
+              <a:rPr sz="1250" b="0" i="0">
+                <a:solidFill>
+                  <a:srgbClr val="56616F"/>
+                </a:solidFill>
+                <a:latin typeface="Calibri"/>
+              </a:rPr>
+              <a:t>The platform is built by a team of five engineers led by the founding engineer of the project.</a:t>
+            </a:r>
+          </a:p>
+        </p:txBody>
+      </p:sp>
+      <p:sp>
+        <p:nvSpPr>
+          <p:cNvPr id="143" name="Rounded Rectangle 142"/>
+          <p:cNvSpPr/>
+          <p:nvPr/>
+        </p:nvSpPr>
+        <p:spPr>
+          <a:xfrm>
+            <a:off x="566928" y="2121408"/>
+            <a:ext cx="4114800" cy="3785616"/>
+          </a:xfrm>
+          <a:prstGeom prst="roundRect">
+            <a:avLst>
+              <a:gd name="adj" fmla="val 2173"/>
+            </a:avLst>
+          </a:prstGeom>
+          <a:solidFill>
+            <a:srgbClr val="FFFFFF"/>
+          </a:solidFill>
+          <a:ln w="12700">
+            <a:solidFill>
+              <a:srgbClr val="E2E7EE"/>
+            </a:solidFill>
+          </a:ln>
+          <a:effectLst>
+            <a:outerShdw sx="100000" sy="100000" kx="0" ky="0" algn="bl" rotWithShape="0" blurRad="88900" dist="25400" dir="8100000">
+              <a:srgbClr val="0C1726">
+                <a:alpha val="8000"/>
+              </a:srgbClr>
+            </a:outerShdw>
+          </a:effectLst>
+        </p:spPr>
+        <p:style>
+          <a:lnRef idx="1">
+            <a:schemeClr val="accent1"/>
+          </a:lnRef>
+          <a:fillRef idx="3">
+            <a:schemeClr val="accent1"/>
+          </a:fillRef>
+          <a:effectRef idx="2">
+            <a:schemeClr val="accent1"/>
+          </a:effectRef>
+          <a:fontRef idx="minor">
+            <a:schemeClr val="lt1"/>
+          </a:fontRef>
+        </p:style>
+        <p:txBody>
+          <a:bodyPr rtlCol="0" anchor="ctr"/>
+          <a:lstStyle/>
+          <a:p>
+            <a:pPr algn="ctr"/>
+          </a:p>
+        </p:txBody>
+      </p:sp>
+      <p:sp>
+        <p:nvSpPr>
+          <p:cNvPr id="144" name="Rectangle 143"/>
+          <p:cNvSpPr/>
+          <p:nvPr/>
+        </p:nvSpPr>
+        <p:spPr>
+          <a:xfrm>
+            <a:off x="585216" y="2121408"/>
+            <a:ext cx="4078224" cy="45720"/>
+          </a:xfrm>
+          <a:prstGeom prst="rect">
+            <a:avLst/>
+          </a:prstGeom>
+          <a:solidFill>
+            <a:srgbClr val="004C8D"/>
+          </a:solidFill>
+          <a:ln>
+            <a:noFill/>
+          </a:ln>
+          <a:effectLst/>
+        </p:spPr>
+        <p:style>
+          <a:lnRef idx="1">
+            <a:schemeClr val="accent1"/>
+          </a:lnRef>
+          <a:fillRef idx="3">
+            <a:schemeClr val="accent1"/>
+          </a:fillRef>
+          <a:effectRef idx="2">
+            <a:schemeClr val="accent1"/>
+          </a:effectRef>
+          <a:fontRef idx="minor">
+            <a:schemeClr val="lt1"/>
+          </a:fontRef>
+        </p:style>
+        <p:txBody>
+          <a:bodyPr rtlCol="0" anchor="ctr"/>
+          <a:lstStyle/>
+          <a:p>
+            <a:pPr algn="ctr"/>
+          </a:p>
+        </p:txBody>
+      </p:sp>
+      <p:sp>
+        <p:nvSpPr>
+          <p:cNvPr id="145" name="Rounded Rectangle 144"/>
+          <p:cNvSpPr/>
+          <p:nvPr/>
+        </p:nvSpPr>
+        <p:spPr>
+          <a:xfrm>
+            <a:off x="1847088" y="2505456"/>
+            <a:ext cx="1554480" cy="1554480"/>
+          </a:xfrm>
+          <a:prstGeom prst="roundRect">
+            <a:avLst>
+              <a:gd name="adj" fmla="val 50000"/>
+            </a:avLst>
+          </a:prstGeom>
+          <a:solidFill>
+            <a:srgbClr val="E3EEF8"/>
+          </a:solidFill>
+          <a:ln w="12700">
+            <a:solidFill>
+              <a:srgbClr val="9CC6E8"/>
+            </a:solidFill>
+          </a:ln>
+          <a:effectLst/>
+        </p:spPr>
+        <p:style>
+          <a:lnRef idx="1">
+            <a:schemeClr val="accent1"/>
+          </a:lnRef>
+          <a:fillRef idx="3">
+            <a:schemeClr val="accent1"/>
+          </a:fillRef>
+          <a:effectRef idx="2">
+            <a:schemeClr val="accent1"/>
+          </a:effectRef>
+          <a:fontRef idx="minor">
+            <a:schemeClr val="lt1"/>
+          </a:fontRef>
+        </p:style>
+        <p:txBody>
+          <a:bodyPr rtlCol="0" anchor="ctr"/>
+          <a:lstStyle/>
+          <a:p>
+            <a:pPr algn="ctr"/>
+          </a:p>
+        </p:txBody>
+      </p:sp>
+      <p:sp>
+        <p:nvSpPr>
+          <p:cNvPr id="146" name="TextBox 145"/>
+          <p:cNvSpPr txBox="1"/>
+          <p:nvPr/>
+        </p:nvSpPr>
+        <p:spPr>
+          <a:xfrm>
+            <a:off x="1847088" y="2505456"/>
+            <a:ext cx="1554480" cy="1554480"/>
+          </a:xfrm>
+          <a:prstGeom prst="rect">
+            <a:avLst/>
+          </a:prstGeom>
+          <a:noFill/>
+        </p:spPr>
+        <p:txBody>
+          <a:bodyPr wrap="square" lIns="18288" rIns="18288" tIns="9144" bIns="9144" anchor="ctr">
+            <a:spAutoFit/>
+          </a:bodyPr>
+          <a:lstStyle/>
+          <a:p>
+            <a:pPr algn="ctr"/>
+            <a:r>
+              <a:rPr sz="4600" b="1" i="0">
+                <a:solidFill>
+                  <a:srgbClr val="004C8D"/>
+                </a:solidFill>
+                <a:latin typeface="Calibri"/>
+              </a:rPr>
+              <a:t>AS</a:t>
+            </a:r>
+          </a:p>
+        </p:txBody>
+      </p:sp>
+      <p:sp>
+        <p:nvSpPr>
+          <p:cNvPr id="147" name="TextBox 146"/>
+          <p:cNvSpPr txBox="1"/>
+          <p:nvPr/>
+        </p:nvSpPr>
+        <p:spPr>
+          <a:xfrm>
+            <a:off x="886968" y="4315968"/>
+            <a:ext cx="3474720" cy="384048"/>
+          </a:xfrm>
+          <a:prstGeom prst="rect">
+            <a:avLst/>
+          </a:prstGeom>
+          <a:noFill/>
+        </p:spPr>
+        <p:txBody>
+          <a:bodyPr wrap="square" lIns="18288" rIns="18288" tIns="9144" bIns="9144" anchor="ctr">
+            <a:spAutoFit/>
+          </a:bodyPr>
+          <a:lstStyle/>
+          <a:p>
+            <a:pPr algn="ctr"/>
+            <a:r>
+              <a:rPr sz="2200" b="1" i="0">
+                <a:solidFill>
+                  <a:srgbClr val="0C1726"/>
+                </a:solidFill>
+                <a:latin typeface="Calibri"/>
+              </a:rPr>
+              <a:t>Aset Seksenali</a:t>
+            </a:r>
+          </a:p>
+        </p:txBody>
+      </p:sp>
+      <p:sp>
+        <p:nvSpPr>
+          <p:cNvPr id="148" name="TextBox 147"/>
+          <p:cNvSpPr txBox="1"/>
+          <p:nvPr/>
+        </p:nvSpPr>
+        <p:spPr>
+          <a:xfrm>
+            <a:off x="886968" y="4727448"/>
+            <a:ext cx="3474720" cy="329184"/>
+          </a:xfrm>
+          <a:prstGeom prst="rect">
+            <a:avLst/>
+          </a:prstGeom>
+          <a:noFill/>
+        </p:spPr>
+        <p:txBody>
+          <a:bodyPr wrap="square" lIns="18288" rIns="18288" tIns="9144" bIns="9144" anchor="ctr">
+            <a:spAutoFit/>
+          </a:bodyPr>
+          <a:lstStyle/>
+          <a:p>
+            <a:pPr algn="ctr"/>
+            <a:r>
+              <a:rPr sz="1300" b="1" i="0">
+                <a:solidFill>
+                  <a:srgbClr val="1166A8"/>
+                </a:solidFill>
+                <a:latin typeface="Calibri"/>
+              </a:rPr>
+              <a:t>Founding engineer · team lead</a:t>
+            </a:r>
+          </a:p>
+        </p:txBody>
+      </p:sp>
+      <p:sp>
+        <p:nvSpPr>
+          <p:cNvPr id="149" name="Rectangle 148"/>
+          <p:cNvSpPr/>
+          <p:nvPr/>
+        </p:nvSpPr>
+        <p:spPr>
+          <a:xfrm>
+            <a:off x="1389888" y="5193792"/>
+            <a:ext cx="2468880" cy="12801"/>
+          </a:xfrm>
+          <a:prstGeom prst="rect">
+            <a:avLst/>
+          </a:prstGeom>
+          <a:solidFill>
+            <a:srgbClr val="E2E7EE"/>
+          </a:solidFill>
+          <a:ln>
+            <a:noFill/>
+          </a:ln>
+          <a:effectLst/>
+        </p:spPr>
+        <p:style>
+          <a:lnRef idx="1">
+            <a:schemeClr val="accent1"/>
+          </a:lnRef>
+          <a:fillRef idx="3">
+            <a:schemeClr val="accent1"/>
+          </a:fillRef>
+          <a:effectRef idx="2">
+            <a:schemeClr val="accent1"/>
+          </a:effectRef>
+          <a:fontRef idx="minor">
+            <a:schemeClr val="lt1"/>
+          </a:fontRef>
+        </p:style>
+        <p:txBody>
+          <a:bodyPr rtlCol="0" anchor="ctr"/>
+          <a:lstStyle/>
+          <a:p>
+            <a:pPr algn="ctr"/>
+          </a:p>
+        </p:txBody>
+      </p:sp>
+      <p:sp>
+        <p:nvSpPr>
+          <p:cNvPr id="150" name="TextBox 149"/>
+          <p:cNvSpPr txBox="1"/>
+          <p:nvPr/>
+        </p:nvSpPr>
+        <p:spPr>
+          <a:xfrm>
+            <a:off x="886968" y="5303520"/>
+            <a:ext cx="3474720" cy="310896"/>
+          </a:xfrm>
+          <a:prstGeom prst="rect">
+            <a:avLst/>
+          </a:prstGeom>
+          <a:noFill/>
+        </p:spPr>
+        <p:txBody>
+          <a:bodyPr wrap="square" lIns="18288" rIns="18288" tIns="9144" bIns="9144" anchor="ctr">
+            <a:spAutoFit/>
+          </a:bodyPr>
+          <a:lstStyle/>
+          <a:p>
+            <a:pPr algn="ctr"/>
+            <a:r>
+              <a:rPr sz="1200" b="0" i="0">
+                <a:solidFill>
+                  <a:srgbClr val="56616F"/>
+                </a:solidFill>
+                <a:latin typeface="Calibri"/>
+              </a:rPr>
+              <a:t>asetseksenali@gmail.com</a:t>
+            </a:r>
+          </a:p>
+        </p:txBody>
+      </p:sp>
+      <p:sp>
+        <p:nvSpPr>
+          <p:cNvPr id="151" name="Rounded Rectangle 150"/>
+          <p:cNvSpPr/>
+          <p:nvPr/>
+        </p:nvSpPr>
+        <p:spPr>
+          <a:xfrm>
+            <a:off x="4901184" y="2121408"/>
+            <a:ext cx="6723583" cy="1127760"/>
+          </a:xfrm>
+          <a:prstGeom prst="roundRect">
+            <a:avLst>
+              <a:gd name="adj" fmla="val 7297"/>
+            </a:avLst>
+          </a:prstGeom>
+          <a:solidFill>
+            <a:srgbClr val="FFFFFF"/>
+          </a:solidFill>
+          <a:ln w="12700">
+            <a:solidFill>
+              <a:srgbClr val="E2E7EE"/>
+            </a:solidFill>
+          </a:ln>
+          <a:effectLst>
+            <a:outerShdw sx="100000" sy="100000" kx="0" ky="0" algn="bl" rotWithShape="0" blurRad="88900" dist="25400" dir="8100000">
+              <a:srgbClr val="0C1726">
+                <a:alpha val="8000"/>
+              </a:srgbClr>
+            </a:outerShdw>
+          </a:effectLst>
+        </p:spPr>
+        <p:style>
+          <a:lnRef idx="1">
+            <a:schemeClr val="accent1"/>
+          </a:lnRef>
+          <a:fillRef idx="3">
+            <a:schemeClr val="accent1"/>
+          </a:fillRef>
+          <a:effectRef idx="2">
+            <a:schemeClr val="accent1"/>
+          </a:effectRef>
+          <a:fontRef idx="minor">
+            <a:schemeClr val="lt1"/>
+          </a:fontRef>
+        </p:style>
+        <p:txBody>
+          <a:bodyPr rtlCol="0" anchor="ctr"/>
+          <a:lstStyle/>
+          <a:p>
+            <a:pPr algn="ctr"/>
+          </a:p>
+        </p:txBody>
+      </p:sp>
+      <p:sp>
+        <p:nvSpPr>
+          <p:cNvPr id="152" name="Rectangle 151"/>
+          <p:cNvSpPr/>
+          <p:nvPr/>
+        </p:nvSpPr>
+        <p:spPr>
+          <a:xfrm>
+            <a:off x="4901184" y="2139696"/>
+            <a:ext cx="45720" cy="1091184"/>
+          </a:xfrm>
+          <a:prstGeom prst="rect">
+            <a:avLst/>
+          </a:prstGeom>
+          <a:solidFill>
+            <a:srgbClr val="004C8D"/>
+          </a:solidFill>
+          <a:ln>
+            <a:noFill/>
+          </a:ln>
+          <a:effectLst/>
+        </p:spPr>
+        <p:style>
+          <a:lnRef idx="1">
+            <a:schemeClr val="accent1"/>
+          </a:lnRef>
+          <a:fillRef idx="3">
+            <a:schemeClr val="accent1"/>
+          </a:fillRef>
+          <a:effectRef idx="2">
+            <a:schemeClr val="accent1"/>
+          </a:effectRef>
+          <a:fontRef idx="minor">
+            <a:schemeClr val="lt1"/>
+          </a:fontRef>
+        </p:style>
+        <p:txBody>
+          <a:bodyPr rtlCol="0" anchor="ctr"/>
+          <a:lstStyle/>
+          <a:p>
+            <a:pPr algn="ctr"/>
+          </a:p>
+        </p:txBody>
+      </p:sp>
+      <p:sp>
+        <p:nvSpPr>
+          <p:cNvPr id="153" name="TextBox 152"/>
+          <p:cNvSpPr txBox="1"/>
+          <p:nvPr/>
+        </p:nvSpPr>
+        <p:spPr>
+          <a:xfrm>
+            <a:off x="5193792" y="2286000"/>
+            <a:ext cx="6174943" cy="219456"/>
+          </a:xfrm>
+          <a:prstGeom prst="rect">
+            <a:avLst/>
+          </a:prstGeom>
+          <a:noFill/>
+        </p:spPr>
+        <p:txBody>
+          <a:bodyPr wrap="square" lIns="18288" rIns="18288" tIns="9144" bIns="9144" anchor="ctr">
+            <a:spAutoFit/>
+          </a:bodyPr>
+          <a:lstStyle/>
+          <a:p>
+            <a:pPr algn="l"/>
+            <a:r>
+              <a:rPr sz="850" b="1" i="0" spc="80">
+                <a:solidFill>
+                  <a:srgbClr val="1166A8"/>
+                </a:solidFill>
+                <a:latin typeface="Calibri"/>
+              </a:rPr>
+              <a:t>ROLE ON THE PROJECT</a:t>
+            </a:r>
+          </a:p>
+        </p:txBody>
+      </p:sp>
+      <p:sp>
+        <p:nvSpPr>
+          <p:cNvPr id="154" name="TextBox 153"/>
+          <p:cNvSpPr txBox="1"/>
+          <p:nvPr/>
+        </p:nvSpPr>
+        <p:spPr>
+          <a:xfrm>
+            <a:off x="5193792" y="2560320"/>
+            <a:ext cx="6156655" cy="560832"/>
+          </a:xfrm>
+          <a:prstGeom prst="rect">
+            <a:avLst/>
+          </a:prstGeom>
+          <a:noFill/>
+        </p:spPr>
+        <p:txBody>
+          <a:bodyPr wrap="square" lIns="18288" rIns="18288" tIns="9144" bIns="9144" anchor="t">
+            <a:spAutoFit/>
+          </a:bodyPr>
+          <a:lstStyle/>
+          <a:p>
+            <a:pPr algn="l">
+              <a:lnSpc>
+                <a:spcPct val="125000"/>
+              </a:lnSpc>
+            </a:pPr>
+            <a:r>
+              <a:rPr sz="1250" b="0" i="0">
+                <a:solidFill>
+                  <a:srgbClr val="56616F"/>
+                </a:solidFill>
+                <a:latin typeface="Calibri"/>
+              </a:rPr>
+              <a:t>Founding and lead engineer of Efes Nexus. Owns the platform architecture, the process model and the Panorama and 1C integrations.</a:t>
+            </a:r>
+          </a:p>
+        </p:txBody>
+      </p:sp>
+      <p:sp>
+        <p:nvSpPr>
+          <p:cNvPr id="155" name="Rounded Rectangle 154"/>
+          <p:cNvSpPr/>
+          <p:nvPr/>
+        </p:nvSpPr>
+        <p:spPr>
+          <a:xfrm>
+            <a:off x="4901184" y="3450336"/>
+            <a:ext cx="6723583" cy="1127760"/>
+          </a:xfrm>
+          <a:prstGeom prst="roundRect">
+            <a:avLst>
+              <a:gd name="adj" fmla="val 7297"/>
+            </a:avLst>
+          </a:prstGeom>
+          <a:solidFill>
+            <a:srgbClr val="FFFFFF"/>
+          </a:solidFill>
+          <a:ln w="12700">
+            <a:solidFill>
+              <a:srgbClr val="E2E7EE"/>
+            </a:solidFill>
+          </a:ln>
+          <a:effectLst>
+            <a:outerShdw sx="100000" sy="100000" kx="0" ky="0" algn="bl" rotWithShape="0" blurRad="88900" dist="25400" dir="8100000">
+              <a:srgbClr val="0C1726">
+                <a:alpha val="8000"/>
+              </a:srgbClr>
+            </a:outerShdw>
+          </a:effectLst>
+        </p:spPr>
+        <p:style>
+          <a:lnRef idx="1">
+            <a:schemeClr val="accent1"/>
+          </a:lnRef>
+          <a:fillRef idx="3">
+            <a:schemeClr val="accent1"/>
+          </a:fillRef>
+          <a:effectRef idx="2">
+            <a:schemeClr val="accent1"/>
+          </a:effectRef>
+          <a:fontRef idx="minor">
+            <a:schemeClr val="lt1"/>
+          </a:fontRef>
+        </p:style>
+        <p:txBody>
+          <a:bodyPr rtlCol="0" anchor="ctr"/>
+          <a:lstStyle/>
+          <a:p>
+            <a:pPr algn="ctr"/>
+          </a:p>
+        </p:txBody>
+      </p:sp>
+      <p:sp>
+        <p:nvSpPr>
+          <p:cNvPr id="156" name="Rectangle 155"/>
+          <p:cNvSpPr/>
+          <p:nvPr/>
+        </p:nvSpPr>
+        <p:spPr>
+          <a:xfrm>
+            <a:off x="4901184" y="3468624"/>
+            <a:ext cx="45720" cy="1091184"/>
+          </a:xfrm>
+          <a:prstGeom prst="rect">
+            <a:avLst/>
+          </a:prstGeom>
+          <a:solidFill>
+            <a:srgbClr val="004C8D"/>
+          </a:solidFill>
+          <a:ln>
+            <a:noFill/>
+          </a:ln>
+          <a:effectLst/>
+        </p:spPr>
+        <p:style>
+          <a:lnRef idx="1">
+            <a:schemeClr val="accent1"/>
+          </a:lnRef>
+          <a:fillRef idx="3">
+            <a:schemeClr val="accent1"/>
+          </a:fillRef>
+          <a:effectRef idx="2">
+            <a:schemeClr val="accent1"/>
+          </a:effectRef>
+          <a:fontRef idx="minor">
+            <a:schemeClr val="lt1"/>
+          </a:fontRef>
+        </p:style>
+        <p:txBody>
+          <a:bodyPr rtlCol="0" anchor="ctr"/>
+          <a:lstStyle/>
+          <a:p>
+            <a:pPr algn="ctr"/>
+          </a:p>
+        </p:txBody>
+      </p:sp>
+      <p:sp>
+        <p:nvSpPr>
+          <p:cNvPr id="157" name="TextBox 156"/>
+          <p:cNvSpPr txBox="1"/>
+          <p:nvPr/>
+        </p:nvSpPr>
+        <p:spPr>
+          <a:xfrm>
+            <a:off x="5193792" y="3614928"/>
+            <a:ext cx="6174943" cy="219456"/>
+          </a:xfrm>
+          <a:prstGeom prst="rect">
+            <a:avLst/>
+          </a:prstGeom>
+          <a:noFill/>
+        </p:spPr>
+        <p:txBody>
+          <a:bodyPr wrap="square" lIns="18288" rIns="18288" tIns="9144" bIns="9144" anchor="ctr">
+            <a:spAutoFit/>
+          </a:bodyPr>
+          <a:lstStyle/>
+          <a:p>
+            <a:pPr algn="l"/>
+            <a:r>
+              <a:rPr sz="850" b="1" i="0" spc="80">
+                <a:solidFill>
+                  <a:srgbClr val="1166A8"/>
+                </a:solidFill>
+                <a:latin typeface="Calibri"/>
+              </a:rPr>
+              <a:t>THE TEAM</a:t>
+            </a:r>
+          </a:p>
+        </p:txBody>
+      </p:sp>
+      <p:sp>
+        <p:nvSpPr>
+          <p:cNvPr id="158" name="TextBox 157"/>
+          <p:cNvSpPr txBox="1"/>
+          <p:nvPr/>
+        </p:nvSpPr>
+        <p:spPr>
+          <a:xfrm>
+            <a:off x="5193792" y="3889248"/>
+            <a:ext cx="6156655" cy="560832"/>
+          </a:xfrm>
+          <a:prstGeom prst="rect">
+            <a:avLst/>
+          </a:prstGeom>
+          <a:noFill/>
+        </p:spPr>
+        <p:txBody>
+          <a:bodyPr wrap="square" lIns="18288" rIns="18288" tIns="9144" bIns="9144" anchor="t">
+            <a:spAutoFit/>
+          </a:bodyPr>
+          <a:lstStyle/>
+          <a:p>
+            <a:pPr algn="l">
+              <a:lnSpc>
+                <a:spcPct val="125000"/>
+              </a:lnSpc>
+            </a:pPr>
+            <a:r>
+              <a:rPr sz="1250" b="0" i="0">
+                <a:solidFill>
+                  <a:srgbClr val="56616F"/>
+                </a:solidFill>
+                <a:latin typeface="Calibri"/>
+              </a:rPr>
+              <a:t>Team lead of four developers: frontend, backend, integrations and rollout. All development is done in-house, with no subcontractors.</a:t>
+            </a:r>
+          </a:p>
+        </p:txBody>
+      </p:sp>
+      <p:sp>
+        <p:nvSpPr>
+          <p:cNvPr id="159" name="Rounded Rectangle 158"/>
+          <p:cNvSpPr/>
+          <p:nvPr/>
+        </p:nvSpPr>
+        <p:spPr>
+          <a:xfrm>
+            <a:off x="4901184" y="4779264"/>
+            <a:ext cx="6723583" cy="1127760"/>
+          </a:xfrm>
+          <a:prstGeom prst="roundRect">
+            <a:avLst>
+              <a:gd name="adj" fmla="val 7297"/>
+            </a:avLst>
+          </a:prstGeom>
+          <a:solidFill>
+            <a:srgbClr val="FFFFFF"/>
+          </a:solidFill>
+          <a:ln w="12700">
+            <a:solidFill>
+              <a:srgbClr val="E2E7EE"/>
+            </a:solidFill>
+          </a:ln>
+          <a:effectLst>
+            <a:outerShdw sx="100000" sy="100000" kx="0" ky="0" algn="bl" rotWithShape="0" blurRad="88900" dist="25400" dir="8100000">
+              <a:srgbClr val="0C1726">
+                <a:alpha val="8000"/>
+              </a:srgbClr>
+            </a:outerShdw>
+          </a:effectLst>
+        </p:spPr>
+        <p:style>
+          <a:lnRef idx="1">
+            <a:schemeClr val="accent1"/>
+          </a:lnRef>
+          <a:fillRef idx="3">
+            <a:schemeClr val="accent1"/>
+          </a:fillRef>
+          <a:effectRef idx="2">
+            <a:schemeClr val="accent1"/>
+          </a:effectRef>
+          <a:fontRef idx="minor">
+            <a:schemeClr val="lt1"/>
+          </a:fontRef>
+        </p:style>
+        <p:txBody>
+          <a:bodyPr rtlCol="0" anchor="ctr"/>
+          <a:lstStyle/>
+          <a:p>
+            <a:pPr algn="ctr"/>
+          </a:p>
+        </p:txBody>
+      </p:sp>
+      <p:sp>
+        <p:nvSpPr>
+          <p:cNvPr id="160" name="Rectangle 159"/>
+          <p:cNvSpPr/>
+          <p:nvPr/>
+        </p:nvSpPr>
+        <p:spPr>
+          <a:xfrm>
+            <a:off x="4901184" y="4797551"/>
+            <a:ext cx="45720" cy="1091184"/>
+          </a:xfrm>
+          <a:prstGeom prst="rect">
+            <a:avLst/>
+          </a:prstGeom>
+          <a:solidFill>
+            <a:srgbClr val="004C8D"/>
+          </a:solidFill>
+          <a:ln>
+            <a:noFill/>
+          </a:ln>
+          <a:effectLst/>
+        </p:spPr>
+        <p:style>
+          <a:lnRef idx="1">
+            <a:schemeClr val="accent1"/>
+          </a:lnRef>
+          <a:fillRef idx="3">
+            <a:schemeClr val="accent1"/>
+          </a:fillRef>
+          <a:effectRef idx="2">
+            <a:schemeClr val="accent1"/>
+          </a:effectRef>
+          <a:fontRef idx="minor">
+            <a:schemeClr val="lt1"/>
+          </a:fontRef>
+        </p:style>
+        <p:txBody>
+          <a:bodyPr rtlCol="0" anchor="ctr"/>
+          <a:lstStyle/>
+          <a:p>
+            <a:pPr algn="ctr"/>
+          </a:p>
+        </p:txBody>
+      </p:sp>
+      <p:sp>
+        <p:nvSpPr>
+          <p:cNvPr id="161" name="TextBox 160"/>
+          <p:cNvSpPr txBox="1"/>
+          <p:nvPr/>
+        </p:nvSpPr>
+        <p:spPr>
+          <a:xfrm>
+            <a:off x="5193792" y="4943856"/>
+            <a:ext cx="6174943" cy="219456"/>
+          </a:xfrm>
+          <a:prstGeom prst="rect">
+            <a:avLst/>
+          </a:prstGeom>
+          <a:noFill/>
+        </p:spPr>
+        <p:txBody>
+          <a:bodyPr wrap="square" lIns="18288" rIns="18288" tIns="9144" bIns="9144" anchor="ctr">
+            <a:spAutoFit/>
+          </a:bodyPr>
+          <a:lstStyle/>
+          <a:p>
+            <a:pPr algn="l"/>
+            <a:r>
+              <a:rPr sz="850" b="1" i="0" spc="80">
+                <a:solidFill>
+                  <a:srgbClr val="1166A8"/>
+                </a:solidFill>
+                <a:latin typeface="Calibri"/>
+              </a:rPr>
+              <a:t>WHAT IS ALREADY DONE</a:t>
+            </a:r>
+          </a:p>
+        </p:txBody>
+      </p:sp>
+      <p:sp>
+        <p:nvSpPr>
+          <p:cNvPr id="162" name="TextBox 161"/>
+          <p:cNvSpPr txBox="1"/>
+          <p:nvPr/>
+        </p:nvSpPr>
+        <p:spPr>
+          <a:xfrm>
+            <a:off x="5193792" y="5218176"/>
+            <a:ext cx="6156655" cy="560832"/>
+          </a:xfrm>
+          <a:prstGeom prst="rect">
+            <a:avLst/>
+          </a:prstGeom>
+          <a:noFill/>
+        </p:spPr>
+        <p:txBody>
+          <a:bodyPr wrap="square" lIns="18288" rIns="18288" tIns="9144" bIns="9144" anchor="t">
+            <a:spAutoFit/>
+          </a:bodyPr>
+          <a:lstStyle/>
+          <a:p>
+            <a:pPr algn="l">
+              <a:lnSpc>
+                <a:spcPct val="125000"/>
+              </a:lnSpc>
+            </a:pPr>
+            <a:r>
+              <a:rPr sz="1250" b="0" i="0">
+                <a:solidFill>
+                  <a:srgbClr val="56616F"/>
+                </a:solidFill>
+                <a:latin typeface="Calibri"/>
+              </a:rPr>
+              <a:t>Three promo-activity BPMN processes modelled, the limits of KZPromotion mapped, and a working platform built and running.</a:t>
+            </a:r>
+          </a:p>
+        </p:txBody>
+      </p:sp>
+    </p:spTree>
+  </p:cSld>
+  <p:clrMapOvr>
+    <a:masterClrMapping/>
+  </p:clrMapOvr>
+</p:sld>
+</file>
+
+<file path=ppt/slides/slide11.xml><?xml version="1.0" encoding="utf-8"?>
+<p:sld xmlns:a="http://schemas.openxmlformats.org/drawingml/2006/main" xmlns:p="http://schemas.openxmlformats.org/presentationml/2006/main" xmlns:r="http://schemas.openxmlformats.org/officeDocument/2006/relationships">
+  <p:cSld>
+    <p:bg>
+      <p:bgPr>
+        <a:solidFill>
+          <a:srgbClr val="F6F8FA"/>
+        </a:solidFill>
+        <a:effectLst/>
+      </p:bgPr>
+    </p:bg>
+    <p:spTree>
+      <p:nvGrpSpPr>
+        <p:cNvPr id="1" name=""/>
+        <p:cNvGrpSpPr/>
+        <p:nvPr/>
+      </p:nvGrpSpPr>
+      <p:grpSpPr/>
+      <p:sp>
+        <p:nvSpPr>
+          <p:cNvPr id="135" name="Shape 125"/>
+          <p:cNvSpPr/>
+          <p:nvPr/>
+        </p:nvSpPr>
+        <p:spPr>
+          <a:xfrm>
+            <a:off x="566928" y="6364224"/>
+            <a:ext cx="11057839" cy="0"/>
+          </a:xfrm>
+          <a:prstGeom prst="line">
+            <a:avLst/>
+          </a:prstGeom>
+          <a:noFill/>
+          <a:ln w="12700">
+            <a:solidFill>
+              <a:srgbClr val="E2E7EE"/>
+            </a:solidFill>
+            <a:prstDash val="solid"/>
+          </a:ln>
+        </p:spPr>
+        <p:txBody>
+          <a:bodyPr/>
+          <a:lstStyle/>
+          <a:p>
+            <a:endParaRPr lang="en-US"/>
+          </a:p>
+        </p:txBody>
+      </p:sp>
+      <p:pic>
+        <p:nvPicPr>
+          <p:cNvPr id="136" name="Image 8" descr="/Users/asetseksenali/Downloads/efes/assets/efes-badge.png"/>
+          <p:cNvPicPr>
+            <a:picLocks noChangeAspect="1"/>
+          </p:cNvPicPr>
+          <p:nvPr/>
+        </p:nvPicPr>
+        <p:blipFill>
+          <a:blip r:embed="rId3"/>
+          <a:stretch>
+            <a:fillRect/>
+          </a:stretch>
+        </p:blipFill>
+        <p:spPr>
+          <a:xfrm>
+            <a:off x="566928" y="6458620"/>
+            <a:ext cx="219456" cy="176967"/>
+          </a:xfrm>
+          <a:prstGeom prst="rect">
+            <a:avLst/>
+          </a:prstGeom>
+        </p:spPr>
+      </p:pic>
+      <p:sp>
+        <p:nvSpPr>
+          <p:cNvPr id="137" name="Text 126"/>
+          <p:cNvSpPr/>
+          <p:nvPr/>
+        </p:nvSpPr>
+        <p:spPr>
+          <a:xfrm>
+            <a:off x="859536" y="6400800"/>
+            <a:ext cx="4572000" cy="292608"/>
+          </a:xfrm>
+          <a:prstGeom prst="rect">
+            <a:avLst/>
+          </a:prstGeom>
+          <a:noFill/>
+          <a:ln/>
+        </p:spPr>
+        <p:txBody>
+          <a:bodyPr wrap="square" rtlCol="0" anchor="ctr"/>
+          <a:lstStyle/>
+          <a:p>
+            <a:pPr marL="0" indent="0">
+              <a:buNone/>
+            </a:pPr>
+            <a:r>
+              <a:rPr lang="en-US" sz="850" dirty="0">
+                <a:solidFill>
+                  <a:srgbClr val="8B94A2"/>
+                </a:solidFill>
+                <a:latin typeface="Calibri" pitchFamily="34" charset="0"/>
+                <a:ea typeface="Calibri" pitchFamily="34" charset="-122"/>
+                <a:cs typeface="Calibri" pitchFamily="34" charset="-120"/>
+              </a:rPr>
+              <a:t>Efes Kazakhstan</a:t>
+            </a:r>
+            <a:endParaRPr lang="en-US" sz="850" dirty="0"/>
+          </a:p>
+        </p:txBody>
+      </p:sp>
+      <p:sp>
+        <p:nvSpPr>
+          <p:cNvPr id="138" name="Text 127"/>
+          <p:cNvSpPr/>
+          <p:nvPr/>
+        </p:nvSpPr>
+        <p:spPr>
+          <a:xfrm>
+            <a:off x="6858000" y="6400800"/>
+            <a:ext cx="4766767" cy="292608"/>
+          </a:xfrm>
+          <a:prstGeom prst="rect">
+            <a:avLst/>
+          </a:prstGeom>
+          <a:noFill/>
+          <a:ln/>
+        </p:spPr>
+        <p:txBody>
+          <a:bodyPr wrap="square" rtlCol="0" anchor="ctr"/>
+          <a:lstStyle/>
+          <a:p>
+            <a:pPr marL="0" indent="0" algn="r">
+              <a:buNone/>
+            </a:pPr>
+            <a:r>
+              <a:rPr lang="en-US" sz="850" dirty="0">
+                <a:solidFill>
+                  <a:srgbClr val="8B94A2"/>
+                </a:solidFill>
+                <a:latin typeface="Calibri" pitchFamily="34" charset="0"/>
+                <a:ea typeface="Calibri" pitchFamily="34" charset="-122"/>
+                <a:cs typeface="Calibri" pitchFamily="34" charset="-120"/>
+              </a:rPr>
+              <a:t>Efes Nexus</a:t>
+            </a:r>
+            <a:endParaRPr lang="en-US" sz="850" dirty="0"/>
+          </a:p>
+        </p:txBody>
+      </p:sp>
+      <p:sp>
+        <p:nvSpPr>
+          <p:cNvPr id="139" name="Rectangle 138"/>
+          <p:cNvSpPr/>
+          <p:nvPr/>
+        </p:nvSpPr>
+        <p:spPr>
+          <a:xfrm>
+            <a:off x="566928" y="589788"/>
+            <a:ext cx="155448" cy="29260"/>
+          </a:xfrm>
+          <a:prstGeom prst="rect">
+            <a:avLst/>
+          </a:prstGeom>
+          <a:solidFill>
+            <a:srgbClr val="004C8D"/>
+          </a:solidFill>
+          <a:ln>
+            <a:noFill/>
+          </a:ln>
+          <a:effectLst/>
+        </p:spPr>
+        <p:style>
+          <a:lnRef idx="1">
+            <a:schemeClr val="accent1"/>
+          </a:lnRef>
+          <a:fillRef idx="3">
+            <a:schemeClr val="accent1"/>
+          </a:fillRef>
+          <a:effectRef idx="2">
+            <a:schemeClr val="accent1"/>
+          </a:effectRef>
+          <a:fontRef idx="minor">
+            <a:schemeClr val="lt1"/>
+          </a:fontRef>
+        </p:style>
+        <p:txBody>
+          <a:bodyPr rtlCol="0" anchor="ctr"/>
+          <a:lstStyle/>
+          <a:p>
+            <a:pPr algn="ctr"/>
+          </a:p>
+        </p:txBody>
+      </p:sp>
+      <p:sp>
+        <p:nvSpPr>
+          <p:cNvPr id="140" name="TextBox 139"/>
+          <p:cNvSpPr txBox="1"/>
+          <p:nvPr/>
+        </p:nvSpPr>
+        <p:spPr>
+          <a:xfrm>
+            <a:off x="795528" y="466344"/>
+            <a:ext cx="8229600" cy="274320"/>
+          </a:xfrm>
+          <a:prstGeom prst="rect">
+            <a:avLst/>
+          </a:prstGeom>
+          <a:noFill/>
+        </p:spPr>
+        <p:txBody>
+          <a:bodyPr wrap="square" lIns="18288" rIns="18288" tIns="9144" bIns="9144" anchor="ctr">
+            <a:spAutoFit/>
+          </a:bodyPr>
+          <a:lstStyle/>
+          <a:p>
+            <a:pPr algn="l"/>
+            <a:r>
+              <a:rPr sz="1050" b="1" i="0" spc="200">
+                <a:solidFill>
+                  <a:srgbClr val="1166A8"/>
+                </a:solidFill>
+                <a:latin typeface="Calibri"/>
+              </a:rPr>
+              <a:t>COMMERCIAL PROPOSAL</a:t>
+            </a:r>
+          </a:p>
+        </p:txBody>
+      </p:sp>
+      <p:sp>
+        <p:nvSpPr>
+          <p:cNvPr id="141" name="TextBox 140"/>
+          <p:cNvSpPr txBox="1"/>
+          <p:nvPr/>
+        </p:nvSpPr>
+        <p:spPr>
+          <a:xfrm>
+            <a:off x="566928" y="786384"/>
+            <a:ext cx="11057839" cy="603504"/>
+          </a:xfrm>
+          <a:prstGeom prst="rect">
+            <a:avLst/>
+          </a:prstGeom>
+          <a:noFill/>
+        </p:spPr>
+        <p:txBody>
+          <a:bodyPr wrap="square" lIns="18288" rIns="18288" tIns="9144" bIns="9144" anchor="ctr">
+            <a:spAutoFit/>
+          </a:bodyPr>
+          <a:lstStyle/>
+          <a:p>
+            <a:pPr algn="l"/>
+            <a:r>
+              <a:rPr sz="2900" b="1" i="0">
+                <a:solidFill>
+                  <a:srgbClr val="0C1726"/>
+                </a:solidFill>
+                <a:latin typeface="Calibri"/>
+              </a:rPr>
+              <a:t>Pricing and phases</a:t>
+            </a:r>
+          </a:p>
+        </p:txBody>
+      </p:sp>
+      <p:sp>
+        <p:nvSpPr>
+          <p:cNvPr id="142" name="TextBox 141"/>
+          <p:cNvSpPr txBox="1"/>
+          <p:nvPr/>
+        </p:nvSpPr>
+        <p:spPr>
+          <a:xfrm>
+            <a:off x="566928" y="1389888"/>
+            <a:ext cx="10881360" cy="640080"/>
+          </a:xfrm>
+          <a:prstGeom prst="rect">
+            <a:avLst/>
+          </a:prstGeom>
+          <a:noFill/>
+        </p:spPr>
+        <p:txBody>
+          <a:bodyPr wrap="square" lIns="18288" rIns="18288" tIns="9144" bIns="9144" anchor="t">
+            <a:spAutoFit/>
+          </a:bodyPr>
+          <a:lstStyle/>
+          <a:p>
+            <a:pPr algn="l">
+              <a:lnSpc>
+                <a:spcPct val="115000"/>
+              </a:lnSpc>
+            </a:pPr>
+            <a:r>
+              <a:rPr sz="1250" b="0" i="0">
+                <a:solidFill>
+                  <a:srgbClr val="56616F"/>
+                </a:solidFill>
+                <a:latin typeface="Calibri"/>
+              </a:rPr>
+              <a:t>The platform is deployed on the Efes Kazakhstan server — no separate infrastructure is needed. Phase 1 covers everything shown in this deck; phase 2 is taken up at the client’s discretion.</a:t>
+            </a:r>
+          </a:p>
+        </p:txBody>
+      </p:sp>
+      <p:sp>
+        <p:nvSpPr>
+          <p:cNvPr id="143" name="Rounded Rectangle 142"/>
+          <p:cNvSpPr/>
+          <p:nvPr/>
+        </p:nvSpPr>
+        <p:spPr>
+          <a:xfrm>
+            <a:off x="566928" y="2121408"/>
+            <a:ext cx="5419191" cy="3419856"/>
+          </a:xfrm>
+          <a:prstGeom prst="roundRect">
+            <a:avLst>
+              <a:gd name="adj" fmla="val 2406"/>
+            </a:avLst>
+          </a:prstGeom>
+          <a:solidFill>
+            <a:srgbClr val="FFFFFF"/>
+          </a:solidFill>
+          <a:ln w="12700">
+            <a:solidFill>
+              <a:srgbClr val="E2E7EE"/>
+            </a:solidFill>
+          </a:ln>
+          <a:effectLst>
+            <a:outerShdw sx="100000" sy="100000" kx="0" ky="0" algn="bl" rotWithShape="0" blurRad="88900" dist="25400" dir="8100000">
+              <a:srgbClr val="0C1726">
+                <a:alpha val="8000"/>
+              </a:srgbClr>
+            </a:outerShdw>
+          </a:effectLst>
+        </p:spPr>
+        <p:style>
+          <a:lnRef idx="1">
+            <a:schemeClr val="accent1"/>
+          </a:lnRef>
+          <a:fillRef idx="3">
+            <a:schemeClr val="accent1"/>
+          </a:fillRef>
+          <a:effectRef idx="2">
+            <a:schemeClr val="accent1"/>
+          </a:effectRef>
+          <a:fontRef idx="minor">
+            <a:schemeClr val="lt1"/>
+          </a:fontRef>
+        </p:style>
+        <p:txBody>
+          <a:bodyPr rtlCol="0" anchor="ctr"/>
+          <a:lstStyle/>
+          <a:p>
+            <a:pPr algn="ctr"/>
+          </a:p>
+        </p:txBody>
+      </p:sp>
+      <p:sp>
+        <p:nvSpPr>
+          <p:cNvPr id="144" name="Rectangle 143"/>
+          <p:cNvSpPr/>
+          <p:nvPr/>
+        </p:nvSpPr>
+        <p:spPr>
+          <a:xfrm>
+            <a:off x="585216" y="2121408"/>
+            <a:ext cx="5382615" cy="45720"/>
+          </a:xfrm>
+          <a:prstGeom prst="rect">
+            <a:avLst/>
+          </a:prstGeom>
+          <a:solidFill>
+            <a:srgbClr val="004C8D"/>
+          </a:solidFill>
+          <a:ln>
+            <a:noFill/>
+          </a:ln>
+          <a:effectLst/>
+        </p:spPr>
+        <p:style>
+          <a:lnRef idx="1">
+            <a:schemeClr val="accent1"/>
+          </a:lnRef>
+          <a:fillRef idx="3">
+            <a:schemeClr val="accent1"/>
+          </a:fillRef>
+          <a:effectRef idx="2">
+            <a:schemeClr val="accent1"/>
+          </a:effectRef>
+          <a:fontRef idx="minor">
+            <a:schemeClr val="lt1"/>
+          </a:fontRef>
+        </p:style>
+        <p:txBody>
+          <a:bodyPr rtlCol="0" anchor="ctr"/>
+          <a:lstStyle/>
+          <a:p>
+            <a:pPr algn="ctr"/>
+          </a:p>
+        </p:txBody>
+      </p:sp>
+      <p:sp>
+        <p:nvSpPr>
+          <p:cNvPr id="145" name="TextBox 144"/>
+          <p:cNvSpPr txBox="1"/>
+          <p:nvPr/>
+        </p:nvSpPr>
+        <p:spPr>
+          <a:xfrm>
+            <a:off x="950976" y="2359152"/>
+            <a:ext cx="4687671" cy="237744"/>
+          </a:xfrm>
+          <a:prstGeom prst="rect">
+            <a:avLst/>
+          </a:prstGeom>
+          <a:noFill/>
+        </p:spPr>
+        <p:txBody>
+          <a:bodyPr wrap="square" lIns="18288" rIns="18288" tIns="9144" bIns="9144" anchor="ctr">
+            <a:spAutoFit/>
+          </a:bodyPr>
+          <a:lstStyle/>
+          <a:p>
+            <a:pPr algn="l"/>
+            <a:r>
+              <a:rPr sz="900" b="1" i="0" spc="100">
+                <a:solidFill>
+                  <a:srgbClr val="1166A8"/>
+                </a:solidFill>
+                <a:latin typeface="Calibri"/>
+              </a:rPr>
+              <a:t>PHASE 1 · PLATFORM ROLLOUT</a:t>
+            </a:r>
+          </a:p>
+        </p:txBody>
+      </p:sp>
+      <p:sp>
+        <p:nvSpPr>
+          <p:cNvPr id="146" name="TextBox 145"/>
+          <p:cNvSpPr txBox="1"/>
+          <p:nvPr/>
+        </p:nvSpPr>
+        <p:spPr>
+          <a:xfrm>
+            <a:off x="950976" y="2670048"/>
+            <a:ext cx="4687671" cy="713232"/>
+          </a:xfrm>
+          <a:prstGeom prst="rect">
+            <a:avLst/>
+          </a:prstGeom>
+          <a:noFill/>
+        </p:spPr>
+        <p:txBody>
+          <a:bodyPr wrap="square" lIns="18288" rIns="18288" tIns="9144" bIns="9144" anchor="ctr">
+            <a:spAutoFit/>
+          </a:bodyPr>
+          <a:lstStyle/>
+          <a:p>
+            <a:pPr algn="l"/>
+            <a:r>
+              <a:rPr sz="4000" b="1" i="0">
+                <a:solidFill>
+                  <a:srgbClr val="004C8D"/>
+                </a:solidFill>
+                <a:latin typeface="Calibri"/>
+              </a:rPr>
+              <a:t>5,000,000 KZT</a:t>
+            </a:r>
+          </a:p>
+        </p:txBody>
+      </p:sp>
+      <p:sp>
+        <p:nvSpPr>
+          <p:cNvPr id="147" name="TextBox 146"/>
+          <p:cNvSpPr txBox="1"/>
+          <p:nvPr/>
+        </p:nvSpPr>
+        <p:spPr>
+          <a:xfrm>
+            <a:off x="969264" y="3419856"/>
+            <a:ext cx="4687671" cy="256032"/>
+          </a:xfrm>
+          <a:prstGeom prst="rect">
+            <a:avLst/>
+          </a:prstGeom>
+          <a:noFill/>
+        </p:spPr>
+        <p:txBody>
+          <a:bodyPr wrap="square" lIns="18288" rIns="18288" tIns="9144" bIns="9144" anchor="ctr">
+            <a:spAutoFit/>
+          </a:bodyPr>
+          <a:lstStyle/>
+          <a:p>
+            <a:pPr algn="l"/>
+            <a:r>
+              <a:rPr sz="1200" b="0" i="1">
+                <a:solidFill>
+                  <a:srgbClr val="8B94A2"/>
+                </a:solidFill>
+                <a:latin typeface="Calibri"/>
+              </a:rPr>
+              <a:t>everything shown in this deck</a:t>
+            </a:r>
+          </a:p>
+        </p:txBody>
+      </p:sp>
+      <p:sp>
+        <p:nvSpPr>
+          <p:cNvPr id="148" name="Rectangle 147"/>
+          <p:cNvSpPr/>
+          <p:nvPr/>
+        </p:nvSpPr>
+        <p:spPr>
+          <a:xfrm>
+            <a:off x="950976" y="3785615"/>
+            <a:ext cx="4651095" cy="12801"/>
+          </a:xfrm>
+          <a:prstGeom prst="rect">
+            <a:avLst/>
+          </a:prstGeom>
+          <a:solidFill>
+            <a:srgbClr val="E2E7EE"/>
+          </a:solidFill>
+          <a:ln>
+            <a:noFill/>
+          </a:ln>
+          <a:effectLst/>
+        </p:spPr>
+        <p:style>
+          <a:lnRef idx="1">
+            <a:schemeClr val="accent1"/>
+          </a:lnRef>
+          <a:fillRef idx="3">
+            <a:schemeClr val="accent1"/>
+          </a:fillRef>
+          <a:effectRef idx="2">
+            <a:schemeClr val="accent1"/>
+          </a:effectRef>
+          <a:fontRef idx="minor">
+            <a:schemeClr val="lt1"/>
+          </a:fontRef>
+        </p:style>
+        <p:txBody>
+          <a:bodyPr rtlCol="0" anchor="ctr"/>
+          <a:lstStyle/>
+          <a:p>
+            <a:pPr algn="ctr"/>
+          </a:p>
+        </p:txBody>
+      </p:sp>
+      <p:sp>
+        <p:nvSpPr>
+          <p:cNvPr id="149" name="Rounded Rectangle 148"/>
+          <p:cNvSpPr/>
+          <p:nvPr/>
+        </p:nvSpPr>
+        <p:spPr>
+          <a:xfrm>
+            <a:off x="969264" y="3995928"/>
+            <a:ext cx="77724" cy="77724"/>
+          </a:xfrm>
+          <a:prstGeom prst="roundRect">
+            <a:avLst>
+              <a:gd name="adj" fmla="val 50000"/>
+            </a:avLst>
+          </a:prstGeom>
+          <a:solidFill>
+            <a:srgbClr val="004C8D"/>
+          </a:solidFill>
+          <a:ln>
+            <a:noFill/>
+          </a:ln>
+          <a:effectLst/>
+        </p:spPr>
+        <p:style>
+          <a:lnRef idx="1">
+            <a:schemeClr val="accent1"/>
+          </a:lnRef>
+          <a:fillRef idx="3">
+            <a:schemeClr val="accent1"/>
+          </a:fillRef>
+          <a:effectRef idx="2">
+            <a:schemeClr val="accent1"/>
+          </a:effectRef>
+          <a:fontRef idx="minor">
+            <a:schemeClr val="lt1"/>
+          </a:fontRef>
+        </p:style>
+        <p:txBody>
+          <a:bodyPr rtlCol="0" anchor="ctr"/>
+          <a:lstStyle/>
+          <a:p>
+            <a:pPr algn="ctr"/>
+          </a:p>
+        </p:txBody>
+      </p:sp>
+      <p:sp>
+        <p:nvSpPr>
+          <p:cNvPr id="150" name="TextBox 149"/>
+          <p:cNvSpPr txBox="1"/>
+          <p:nvPr/>
+        </p:nvSpPr>
+        <p:spPr>
+          <a:xfrm>
+            <a:off x="1207007" y="3895344"/>
+            <a:ext cx="4413351" cy="274320"/>
+          </a:xfrm>
+          <a:prstGeom prst="rect">
+            <a:avLst/>
+          </a:prstGeom>
+          <a:noFill/>
+        </p:spPr>
+        <p:txBody>
+          <a:bodyPr wrap="square" lIns="18288" rIns="18288" tIns="9144" bIns="9144" anchor="ctr">
+            <a:spAutoFit/>
+          </a:bodyPr>
+          <a:lstStyle/>
+          <a:p>
+            <a:pPr algn="l"/>
+            <a:r>
+              <a:rPr sz="1150" b="0" i="0">
+                <a:solidFill>
+                  <a:srgbClr val="56616F"/>
+                </a:solidFill>
+                <a:latin typeface="Calibri"/>
+              </a:rPr>
+              <a:t>Creating, changing and closing promo activities</a:t>
+            </a:r>
+          </a:p>
+        </p:txBody>
+      </p:sp>
+      <p:sp>
+        <p:nvSpPr>
+          <p:cNvPr id="151" name="Rounded Rectangle 150"/>
+          <p:cNvSpPr/>
+          <p:nvPr/>
+        </p:nvSpPr>
+        <p:spPr>
+          <a:xfrm>
+            <a:off x="969264" y="4311396"/>
+            <a:ext cx="77724" cy="77724"/>
+          </a:xfrm>
+          <a:prstGeom prst="roundRect">
+            <a:avLst>
+              <a:gd name="adj" fmla="val 50000"/>
+            </a:avLst>
+          </a:prstGeom>
+          <a:solidFill>
+            <a:srgbClr val="004C8D"/>
+          </a:solidFill>
+          <a:ln>
+            <a:noFill/>
+          </a:ln>
+          <a:effectLst/>
+        </p:spPr>
+        <p:style>
+          <a:lnRef idx="1">
+            <a:schemeClr val="accent1"/>
+          </a:lnRef>
+          <a:fillRef idx="3">
+            <a:schemeClr val="accent1"/>
+          </a:fillRef>
+          <a:effectRef idx="2">
+            <a:schemeClr val="accent1"/>
+          </a:effectRef>
+          <a:fontRef idx="minor">
+            <a:schemeClr val="lt1"/>
+          </a:fontRef>
+        </p:style>
+        <p:txBody>
+          <a:bodyPr rtlCol="0" anchor="ctr"/>
+          <a:lstStyle/>
+          <a:p>
+            <a:pPr algn="ctr"/>
+          </a:p>
+        </p:txBody>
+      </p:sp>
+      <p:sp>
+        <p:nvSpPr>
+          <p:cNvPr id="152" name="TextBox 151"/>
+          <p:cNvSpPr txBox="1"/>
+          <p:nvPr/>
+        </p:nvSpPr>
+        <p:spPr>
+          <a:xfrm>
+            <a:off x="1207007" y="4210812"/>
+            <a:ext cx="4413351" cy="274320"/>
+          </a:xfrm>
+          <a:prstGeom prst="rect">
+            <a:avLst/>
+          </a:prstGeom>
+          <a:noFill/>
+        </p:spPr>
+        <p:txBody>
+          <a:bodyPr wrap="square" lIns="18288" rIns="18288" tIns="9144" bIns="9144" anchor="ctr">
+            <a:spAutoFit/>
+          </a:bodyPr>
+          <a:lstStyle/>
+          <a:p>
+            <a:pPr algn="l"/>
+            <a:r>
+              <a:rPr sz="1150" b="0" i="0">
+                <a:solidFill>
+                  <a:srgbClr val="56616F"/>
+                </a:solidFill>
+                <a:latin typeface="Calibri"/>
+              </a:rPr>
+              <a:t>Partner notifications and Panorama synchronisation</a:t>
+            </a:r>
+          </a:p>
+        </p:txBody>
+      </p:sp>
+      <p:sp>
+        <p:nvSpPr>
+          <p:cNvPr id="153" name="Rounded Rectangle 152"/>
+          <p:cNvSpPr/>
+          <p:nvPr/>
+        </p:nvSpPr>
+        <p:spPr>
+          <a:xfrm>
+            <a:off x="969264" y="4626864"/>
+            <a:ext cx="77724" cy="77724"/>
+          </a:xfrm>
+          <a:prstGeom prst="roundRect">
+            <a:avLst>
+              <a:gd name="adj" fmla="val 50000"/>
+            </a:avLst>
+          </a:prstGeom>
+          <a:solidFill>
+            <a:srgbClr val="004C8D"/>
+          </a:solidFill>
+          <a:ln>
+            <a:noFill/>
+          </a:ln>
+          <a:effectLst/>
+        </p:spPr>
+        <p:style>
+          <a:lnRef idx="1">
+            <a:schemeClr val="accent1"/>
+          </a:lnRef>
+          <a:fillRef idx="3">
+            <a:schemeClr val="accent1"/>
+          </a:fillRef>
+          <a:effectRef idx="2">
+            <a:schemeClr val="accent1"/>
+          </a:effectRef>
+          <a:fontRef idx="minor">
+            <a:schemeClr val="lt1"/>
+          </a:fontRef>
+        </p:style>
+        <p:txBody>
+          <a:bodyPr rtlCol="0" anchor="ctr"/>
+          <a:lstStyle/>
+          <a:p>
+            <a:pPr algn="ctr"/>
+          </a:p>
+        </p:txBody>
+      </p:sp>
+      <p:sp>
+        <p:nvSpPr>
+          <p:cNvPr id="154" name="TextBox 153"/>
+          <p:cNvSpPr txBox="1"/>
+          <p:nvPr/>
+        </p:nvSpPr>
+        <p:spPr>
+          <a:xfrm>
+            <a:off x="1207007" y="4526279"/>
+            <a:ext cx="4413351" cy="274320"/>
+          </a:xfrm>
+          <a:prstGeom prst="rect">
+            <a:avLst/>
+          </a:prstGeom>
+          <a:noFill/>
+        </p:spPr>
+        <p:txBody>
+          <a:bodyPr wrap="square" lIns="18288" rIns="18288" tIns="9144" bIns="9144" anchor="ctr">
+            <a:spAutoFit/>
+          </a:bodyPr>
+          <a:lstStyle/>
+          <a:p>
+            <a:pPr algn="l"/>
+            <a:r>
+              <a:rPr sz="1150" b="0" i="0">
+                <a:solidFill>
+                  <a:srgbClr val="56616F"/>
+                </a:solidFill>
+                <a:latin typeface="Calibri"/>
+              </a:rPr>
+              <a:t>Compensation calculations and report exports</a:t>
+            </a:r>
+          </a:p>
+        </p:txBody>
+      </p:sp>
+      <p:sp>
+        <p:nvSpPr>
+          <p:cNvPr id="155" name="Rounded Rectangle 154"/>
+          <p:cNvSpPr/>
+          <p:nvPr/>
+        </p:nvSpPr>
+        <p:spPr>
+          <a:xfrm>
+            <a:off x="969264" y="4942332"/>
+            <a:ext cx="77724" cy="77724"/>
+          </a:xfrm>
+          <a:prstGeom prst="roundRect">
+            <a:avLst>
+              <a:gd name="adj" fmla="val 50000"/>
+            </a:avLst>
+          </a:prstGeom>
+          <a:solidFill>
+            <a:srgbClr val="004C8D"/>
+          </a:solidFill>
+          <a:ln>
+            <a:noFill/>
+          </a:ln>
+          <a:effectLst/>
+        </p:spPr>
+        <p:style>
+          <a:lnRef idx="1">
+            <a:schemeClr val="accent1"/>
+          </a:lnRef>
+          <a:fillRef idx="3">
+            <a:schemeClr val="accent1"/>
+          </a:fillRef>
+          <a:effectRef idx="2">
+            <a:schemeClr val="accent1"/>
+          </a:effectRef>
+          <a:fontRef idx="minor">
+            <a:schemeClr val="lt1"/>
+          </a:fontRef>
+        </p:style>
+        <p:txBody>
+          <a:bodyPr rtlCol="0" anchor="ctr"/>
+          <a:lstStyle/>
+          <a:p>
+            <a:pPr algn="ctr"/>
+          </a:p>
+        </p:txBody>
+      </p:sp>
+      <p:sp>
+        <p:nvSpPr>
+          <p:cNvPr id="156" name="TextBox 155"/>
+          <p:cNvSpPr txBox="1"/>
+          <p:nvPr/>
+        </p:nvSpPr>
+        <p:spPr>
+          <a:xfrm>
+            <a:off x="1207007" y="4841748"/>
+            <a:ext cx="4413351" cy="274320"/>
+          </a:xfrm>
+          <a:prstGeom prst="rect">
+            <a:avLst/>
+          </a:prstGeom>
+          <a:noFill/>
+        </p:spPr>
+        <p:txBody>
+          <a:bodyPr wrap="square" lIns="18288" rIns="18288" tIns="9144" bIns="9144" anchor="ctr">
+            <a:spAutoFit/>
+          </a:bodyPr>
+          <a:lstStyle/>
+          <a:p>
+            <a:pPr algn="l"/>
+            <a:r>
+              <a:rPr sz="1150" b="0" i="0">
+                <a:solidFill>
+                  <a:srgbClr val="56616F"/>
+                </a:solidFill>
+                <a:latin typeface="Calibri"/>
+              </a:rPr>
+              <a:t>Partner stock checks and promo pre-calculations</a:t>
+            </a:r>
+          </a:p>
+        </p:txBody>
+      </p:sp>
+      <p:sp>
+        <p:nvSpPr>
+          <p:cNvPr id="157" name="Rounded Rectangle 156"/>
+          <p:cNvSpPr/>
+          <p:nvPr/>
+        </p:nvSpPr>
+        <p:spPr>
+          <a:xfrm>
+            <a:off x="969264" y="5257800"/>
+            <a:ext cx="77724" cy="77724"/>
+          </a:xfrm>
+          <a:prstGeom prst="roundRect">
+            <a:avLst>
+              <a:gd name="adj" fmla="val 50000"/>
+            </a:avLst>
+          </a:prstGeom>
+          <a:solidFill>
+            <a:srgbClr val="004C8D"/>
+          </a:solidFill>
+          <a:ln>
+            <a:noFill/>
+          </a:ln>
+          <a:effectLst/>
+        </p:spPr>
+        <p:style>
+          <a:lnRef idx="1">
+            <a:schemeClr val="accent1"/>
+          </a:lnRef>
+          <a:fillRef idx="3">
+            <a:schemeClr val="accent1"/>
+          </a:fillRef>
+          <a:effectRef idx="2">
+            <a:schemeClr val="accent1"/>
+          </a:effectRef>
+          <a:fontRef idx="minor">
+            <a:schemeClr val="lt1"/>
+          </a:fontRef>
+        </p:style>
+        <p:txBody>
+          <a:bodyPr rtlCol="0" anchor="ctr"/>
+          <a:lstStyle/>
+          <a:p>
+            <a:pPr algn="ctr"/>
+          </a:p>
+        </p:txBody>
+      </p:sp>
+      <p:sp>
+        <p:nvSpPr>
+          <p:cNvPr id="158" name="TextBox 157"/>
+          <p:cNvSpPr txBox="1"/>
+          <p:nvPr/>
+        </p:nvSpPr>
+        <p:spPr>
+          <a:xfrm>
+            <a:off x="1207007" y="5157216"/>
+            <a:ext cx="4413351" cy="274320"/>
+          </a:xfrm>
+          <a:prstGeom prst="rect">
+            <a:avLst/>
+          </a:prstGeom>
+          <a:noFill/>
+        </p:spPr>
+        <p:txBody>
+          <a:bodyPr wrap="square" lIns="18288" rIns="18288" tIns="9144" bIns="9144" anchor="ctr">
+            <a:spAutoFit/>
+          </a:bodyPr>
+          <a:lstStyle/>
+          <a:p>
+            <a:pPr algn="l"/>
+            <a:r>
+              <a:rPr sz="1150" b="0" i="0">
+                <a:solidFill>
+                  <a:srgbClr val="56616F"/>
+                </a:solidFill>
+                <a:latin typeface="Calibri"/>
+              </a:rPr>
+              <a:t>Deployment on the Efes Kazakhstan server, team training</a:t>
+            </a:r>
+          </a:p>
+        </p:txBody>
+      </p:sp>
+      <p:sp>
+        <p:nvSpPr>
+          <p:cNvPr id="159" name="Rounded Rectangle 158"/>
+          <p:cNvSpPr/>
+          <p:nvPr/>
+        </p:nvSpPr>
+        <p:spPr>
+          <a:xfrm>
+            <a:off x="6205575" y="2121408"/>
+            <a:ext cx="5419191" cy="3419856"/>
+          </a:xfrm>
+          <a:prstGeom prst="roundRect">
+            <a:avLst>
+              <a:gd name="adj" fmla="val 2406"/>
+            </a:avLst>
+          </a:prstGeom>
+          <a:solidFill>
+            <a:srgbClr val="FFFFFF"/>
+          </a:solidFill>
+          <a:ln w="12700">
+            <a:solidFill>
+              <a:srgbClr val="E2E7EE"/>
+            </a:solidFill>
+          </a:ln>
+          <a:effectLst>
+            <a:outerShdw sx="100000" sy="100000" kx="0" ky="0" algn="bl" rotWithShape="0" blurRad="88900" dist="25400" dir="8100000">
+              <a:srgbClr val="0C1726">
+                <a:alpha val="8000"/>
+              </a:srgbClr>
+            </a:outerShdw>
+          </a:effectLst>
+        </p:spPr>
+        <p:style>
+          <a:lnRef idx="1">
+            <a:schemeClr val="accent1"/>
+          </a:lnRef>
+          <a:fillRef idx="3">
+            <a:schemeClr val="accent1"/>
+          </a:fillRef>
+          <a:effectRef idx="2">
+            <a:schemeClr val="accent1"/>
+          </a:effectRef>
+          <a:fontRef idx="minor">
+            <a:schemeClr val="lt1"/>
+          </a:fontRef>
+        </p:style>
+        <p:txBody>
+          <a:bodyPr rtlCol="0" anchor="ctr"/>
+          <a:lstStyle/>
+          <a:p>
+            <a:pPr algn="ctr"/>
+          </a:p>
+        </p:txBody>
+      </p:sp>
+      <p:sp>
+        <p:nvSpPr>
+          <p:cNvPr id="160" name="Rectangle 159"/>
+          <p:cNvSpPr/>
+          <p:nvPr/>
+        </p:nvSpPr>
+        <p:spPr>
+          <a:xfrm>
+            <a:off x="6223863" y="2121408"/>
+            <a:ext cx="5382615" cy="45720"/>
+          </a:xfrm>
+          <a:prstGeom prst="rect">
+            <a:avLst/>
+          </a:prstGeom>
+          <a:solidFill>
+            <a:srgbClr val="9CC6E8"/>
+          </a:solidFill>
+          <a:ln>
+            <a:noFill/>
+          </a:ln>
+          <a:effectLst/>
+        </p:spPr>
+        <p:style>
+          <a:lnRef idx="1">
+            <a:schemeClr val="accent1"/>
+          </a:lnRef>
+          <a:fillRef idx="3">
+            <a:schemeClr val="accent1"/>
+          </a:fillRef>
+          <a:effectRef idx="2">
+            <a:schemeClr val="accent1"/>
+          </a:effectRef>
+          <a:fontRef idx="minor">
+            <a:schemeClr val="lt1"/>
+          </a:fontRef>
+        </p:style>
+        <p:txBody>
+          <a:bodyPr rtlCol="0" anchor="ctr"/>
+          <a:lstStyle/>
+          <a:p>
+            <a:pPr algn="ctr"/>
+          </a:p>
+        </p:txBody>
+      </p:sp>
+      <p:sp>
+        <p:nvSpPr>
+          <p:cNvPr id="161" name="TextBox 160"/>
+          <p:cNvSpPr txBox="1"/>
+          <p:nvPr/>
+        </p:nvSpPr>
+        <p:spPr>
+          <a:xfrm>
+            <a:off x="6589623" y="2359152"/>
+            <a:ext cx="4687671" cy="237744"/>
+          </a:xfrm>
+          <a:prstGeom prst="rect">
+            <a:avLst/>
+          </a:prstGeom>
+          <a:noFill/>
+        </p:spPr>
+        <p:txBody>
+          <a:bodyPr wrap="square" lIns="18288" rIns="18288" tIns="9144" bIns="9144" anchor="ctr">
+            <a:spAutoFit/>
+          </a:bodyPr>
+          <a:lstStyle/>
+          <a:p>
+            <a:pPr algn="l"/>
+            <a:r>
+              <a:rPr sz="900" b="1" i="0" spc="100">
+                <a:solidFill>
+                  <a:srgbClr val="8B94A2"/>
+                </a:solidFill>
+                <a:latin typeface="Calibri"/>
+              </a:rPr>
+              <a:t>PHASE 2 · OPTIONAL</a:t>
+            </a:r>
+          </a:p>
+        </p:txBody>
+      </p:sp>
+      <p:sp>
+        <p:nvSpPr>
+          <p:cNvPr id="162" name="TextBox 161"/>
+          <p:cNvSpPr txBox="1"/>
+          <p:nvPr/>
+        </p:nvSpPr>
+        <p:spPr>
+          <a:xfrm>
+            <a:off x="6589623" y="2670048"/>
+            <a:ext cx="4687671" cy="713232"/>
+          </a:xfrm>
+          <a:prstGeom prst="rect">
+            <a:avLst/>
+          </a:prstGeom>
+          <a:noFill/>
+        </p:spPr>
+        <p:txBody>
+          <a:bodyPr wrap="square" lIns="18288" rIns="18288" tIns="9144" bIns="9144" anchor="ctr">
+            <a:spAutoFit/>
+          </a:bodyPr>
+          <a:lstStyle/>
+          <a:p>
+            <a:pPr algn="l"/>
+            <a:r>
+              <a:rPr sz="4000" b="1" i="0">
+                <a:solidFill>
+                  <a:srgbClr val="56616F"/>
+                </a:solidFill>
+                <a:latin typeface="Calibri"/>
+              </a:rPr>
+              <a:t>+ 5,000,000 KZT</a:t>
+            </a:r>
+          </a:p>
+        </p:txBody>
+      </p:sp>
+      <p:sp>
+        <p:nvSpPr>
+          <p:cNvPr id="163" name="TextBox 162"/>
+          <p:cNvSpPr txBox="1"/>
+          <p:nvPr/>
+        </p:nvSpPr>
+        <p:spPr>
+          <a:xfrm>
+            <a:off x="6607911" y="3419856"/>
+            <a:ext cx="4687671" cy="256032"/>
+          </a:xfrm>
+          <a:prstGeom prst="rect">
+            <a:avLst/>
+          </a:prstGeom>
+          <a:noFill/>
+        </p:spPr>
+        <p:txBody>
+          <a:bodyPr wrap="square" lIns="18288" rIns="18288" tIns="9144" bIns="9144" anchor="ctr">
+            <a:spAutoFit/>
+          </a:bodyPr>
+          <a:lstStyle/>
+          <a:p>
+            <a:pPr algn="l"/>
+            <a:r>
+              <a:rPr sz="1200" b="0" i="1">
+                <a:solidFill>
+                  <a:srgbClr val="8B94A2"/>
+                </a:solidFill>
+                <a:latin typeface="Calibri"/>
+              </a:rPr>
+              <a:t>further development possibilities</a:t>
+            </a:r>
+          </a:p>
+        </p:txBody>
+      </p:sp>
+      <p:sp>
+        <p:nvSpPr>
+          <p:cNvPr id="164" name="Rectangle 163"/>
+          <p:cNvSpPr/>
+          <p:nvPr/>
+        </p:nvSpPr>
+        <p:spPr>
+          <a:xfrm>
+            <a:off x="6589623" y="3785615"/>
+            <a:ext cx="4651095" cy="12801"/>
+          </a:xfrm>
+          <a:prstGeom prst="rect">
+            <a:avLst/>
+          </a:prstGeom>
+          <a:solidFill>
+            <a:srgbClr val="E2E7EE"/>
+          </a:solidFill>
+          <a:ln>
+            <a:noFill/>
+          </a:ln>
+          <a:effectLst/>
+        </p:spPr>
+        <p:style>
+          <a:lnRef idx="1">
+            <a:schemeClr val="accent1"/>
+          </a:lnRef>
+          <a:fillRef idx="3">
+            <a:schemeClr val="accent1"/>
+          </a:fillRef>
+          <a:effectRef idx="2">
+            <a:schemeClr val="accent1"/>
+          </a:effectRef>
+          <a:fontRef idx="minor">
+            <a:schemeClr val="lt1"/>
+          </a:fontRef>
+        </p:style>
+        <p:txBody>
+          <a:bodyPr rtlCol="0" anchor="ctr"/>
+          <a:lstStyle/>
+          <a:p>
+            <a:pPr algn="ctr"/>
+          </a:p>
+        </p:txBody>
+      </p:sp>
+      <p:sp>
+        <p:nvSpPr>
+          <p:cNvPr id="165" name="Rounded Rectangle 164"/>
+          <p:cNvSpPr/>
+          <p:nvPr/>
+        </p:nvSpPr>
+        <p:spPr>
+          <a:xfrm>
+            <a:off x="6607911" y="3995928"/>
+            <a:ext cx="77724" cy="77724"/>
+          </a:xfrm>
+          <a:prstGeom prst="roundRect">
+            <a:avLst>
+              <a:gd name="adj" fmla="val 50000"/>
+            </a:avLst>
+          </a:prstGeom>
+          <a:solidFill>
+            <a:srgbClr val="9CC6E8"/>
+          </a:solidFill>
+          <a:ln>
+            <a:noFill/>
+          </a:ln>
+          <a:effectLst/>
+        </p:spPr>
+        <p:style>
+          <a:lnRef idx="1">
+            <a:schemeClr val="accent1"/>
+          </a:lnRef>
+          <a:fillRef idx="3">
+            <a:schemeClr val="accent1"/>
+          </a:fillRef>
+          <a:effectRef idx="2">
+            <a:schemeClr val="accent1"/>
+          </a:effectRef>
+          <a:fontRef idx="minor">
+            <a:schemeClr val="lt1"/>
+          </a:fontRef>
+        </p:style>
+        <p:txBody>
+          <a:bodyPr rtlCol="0" anchor="ctr"/>
+          <a:lstStyle/>
+          <a:p>
+            <a:pPr algn="ctr"/>
+          </a:p>
+        </p:txBody>
+      </p:sp>
+      <p:sp>
+        <p:nvSpPr>
+          <p:cNvPr id="166" name="TextBox 165"/>
+          <p:cNvSpPr txBox="1"/>
+          <p:nvPr/>
+        </p:nvSpPr>
+        <p:spPr>
+          <a:xfrm>
+            <a:off x="6845655" y="3895344"/>
+            <a:ext cx="4413351" cy="274320"/>
+          </a:xfrm>
+          <a:prstGeom prst="rect">
+            <a:avLst/>
+          </a:prstGeom>
+          <a:noFill/>
+        </p:spPr>
+        <p:txBody>
+          <a:bodyPr wrap="square" lIns="18288" rIns="18288" tIns="9144" bIns="9144" anchor="ctr">
+            <a:spAutoFit/>
+          </a:bodyPr>
+          <a:lstStyle/>
+          <a:p>
+            <a:pPr algn="l"/>
+            <a:r>
+              <a:rPr sz="1150" b="0" i="0">
+                <a:solidFill>
+                  <a:srgbClr val="56616F"/>
+                </a:solidFill>
+                <a:latin typeface="Calibri"/>
+              </a:rPr>
+              <a:t>AI Search &amp; Knowledge Base — search across promo history</a:t>
+            </a:r>
+          </a:p>
+        </p:txBody>
+      </p:sp>
+      <p:sp>
+        <p:nvSpPr>
+          <p:cNvPr id="167" name="Rounded Rectangle 166"/>
+          <p:cNvSpPr/>
+          <p:nvPr/>
+        </p:nvSpPr>
+        <p:spPr>
+          <a:xfrm>
+            <a:off x="6607911" y="4311396"/>
+            <a:ext cx="77724" cy="77724"/>
+          </a:xfrm>
+          <a:prstGeom prst="roundRect">
+            <a:avLst>
+              <a:gd name="adj" fmla="val 50000"/>
+            </a:avLst>
+          </a:prstGeom>
+          <a:solidFill>
+            <a:srgbClr val="9CC6E8"/>
+          </a:solidFill>
+          <a:ln>
+            <a:noFill/>
+          </a:ln>
+          <a:effectLst/>
+        </p:spPr>
+        <p:style>
+          <a:lnRef idx="1">
+            <a:schemeClr val="accent1"/>
+          </a:lnRef>
+          <a:fillRef idx="3">
+            <a:schemeClr val="accent1"/>
+          </a:fillRef>
+          <a:effectRef idx="2">
+            <a:schemeClr val="accent1"/>
+          </a:effectRef>
+          <a:fontRef idx="minor">
+            <a:schemeClr val="lt1"/>
+          </a:fontRef>
+        </p:style>
+        <p:txBody>
+          <a:bodyPr rtlCol="0" anchor="ctr"/>
+          <a:lstStyle/>
+          <a:p>
+            <a:pPr algn="ctr"/>
+          </a:p>
+        </p:txBody>
+      </p:sp>
+      <p:sp>
+        <p:nvSpPr>
+          <p:cNvPr id="168" name="TextBox 167"/>
+          <p:cNvSpPr txBox="1"/>
+          <p:nvPr/>
+        </p:nvSpPr>
+        <p:spPr>
+          <a:xfrm>
+            <a:off x="6845655" y="4210812"/>
+            <a:ext cx="4413351" cy="274320"/>
+          </a:xfrm>
+          <a:prstGeom prst="rect">
+            <a:avLst/>
+          </a:prstGeom>
+          <a:noFill/>
+        </p:spPr>
+        <p:txBody>
+          <a:bodyPr wrap="square" lIns="18288" rIns="18288" tIns="9144" bIns="9144" anchor="ctr">
+            <a:spAutoFit/>
+          </a:bodyPr>
+          <a:lstStyle/>
+          <a:p>
+            <a:pPr algn="l"/>
+            <a:r>
+              <a:rPr sz="1150" b="0" i="0">
+                <a:solidFill>
+                  <a:srgbClr val="56616F"/>
+                </a:solidFill>
+                <a:latin typeface="Calibri"/>
+              </a:rPr>
+              <a:t>1C Invoice Validation — checking exports and invoices</a:t>
+            </a:r>
+          </a:p>
+        </p:txBody>
+      </p:sp>
+      <p:sp>
+        <p:nvSpPr>
+          <p:cNvPr id="169" name="Rounded Rectangle 168"/>
+          <p:cNvSpPr/>
+          <p:nvPr/>
+        </p:nvSpPr>
+        <p:spPr>
+          <a:xfrm>
+            <a:off x="6607911" y="4626864"/>
+            <a:ext cx="77724" cy="77724"/>
+          </a:xfrm>
+          <a:prstGeom prst="roundRect">
+            <a:avLst>
+              <a:gd name="adj" fmla="val 50000"/>
+            </a:avLst>
+          </a:prstGeom>
+          <a:solidFill>
+            <a:srgbClr val="9CC6E8"/>
+          </a:solidFill>
+          <a:ln>
+            <a:noFill/>
+          </a:ln>
+          <a:effectLst/>
+        </p:spPr>
+        <p:style>
+          <a:lnRef idx="1">
+            <a:schemeClr val="accent1"/>
+          </a:lnRef>
+          <a:fillRef idx="3">
+            <a:schemeClr val="accent1"/>
+          </a:fillRef>
+          <a:effectRef idx="2">
+            <a:schemeClr val="accent1"/>
+          </a:effectRef>
+          <a:fontRef idx="minor">
+            <a:schemeClr val="lt1"/>
+          </a:fontRef>
+        </p:style>
+        <p:txBody>
+          <a:bodyPr rtlCol="0" anchor="ctr"/>
+          <a:lstStyle/>
+          <a:p>
+            <a:pPr algn="ctr"/>
+          </a:p>
+        </p:txBody>
+      </p:sp>
+      <p:sp>
+        <p:nvSpPr>
+          <p:cNvPr id="170" name="TextBox 169"/>
+          <p:cNvSpPr txBox="1"/>
+          <p:nvPr/>
+        </p:nvSpPr>
+        <p:spPr>
+          <a:xfrm>
+            <a:off x="6845655" y="4526279"/>
+            <a:ext cx="4413351" cy="274320"/>
+          </a:xfrm>
+          <a:prstGeom prst="rect">
+            <a:avLst/>
+          </a:prstGeom>
+          <a:noFill/>
+        </p:spPr>
+        <p:txBody>
+          <a:bodyPr wrap="square" lIns="18288" rIns="18288" tIns="9144" bIns="9144" anchor="ctr">
+            <a:spAutoFit/>
+          </a:bodyPr>
+          <a:lstStyle/>
+          <a:p>
+            <a:pPr algn="l"/>
+            <a:r>
+              <a:rPr sz="1150" b="0" i="0">
+                <a:solidFill>
+                  <a:srgbClr val="56616F"/>
+                </a:solidFill>
+                <a:latin typeface="Calibri"/>
+              </a:rPr>
+              <a:t>Scaling calculations to other compensation types</a:t>
+            </a:r>
+          </a:p>
+        </p:txBody>
+      </p:sp>
+      <p:sp>
+        <p:nvSpPr>
+          <p:cNvPr id="171" name="Rounded Rectangle 170"/>
+          <p:cNvSpPr/>
+          <p:nvPr/>
+        </p:nvSpPr>
+        <p:spPr>
+          <a:xfrm>
+            <a:off x="6607911" y="4942332"/>
+            <a:ext cx="77724" cy="77724"/>
+          </a:xfrm>
+          <a:prstGeom prst="roundRect">
+            <a:avLst>
+              <a:gd name="adj" fmla="val 50000"/>
+            </a:avLst>
+          </a:prstGeom>
+          <a:solidFill>
+            <a:srgbClr val="9CC6E8"/>
+          </a:solidFill>
+          <a:ln>
+            <a:noFill/>
+          </a:ln>
+          <a:effectLst/>
+        </p:spPr>
+        <p:style>
+          <a:lnRef idx="1">
+            <a:schemeClr val="accent1"/>
+          </a:lnRef>
+          <a:fillRef idx="3">
+            <a:schemeClr val="accent1"/>
+          </a:fillRef>
+          <a:effectRef idx="2">
+            <a:schemeClr val="accent1"/>
+          </a:effectRef>
+          <a:fontRef idx="minor">
+            <a:schemeClr val="lt1"/>
+          </a:fontRef>
+        </p:style>
+        <p:txBody>
+          <a:bodyPr rtlCol="0" anchor="ctr"/>
+          <a:lstStyle/>
+          <a:p>
+            <a:pPr algn="ctr"/>
+          </a:p>
+        </p:txBody>
+      </p:sp>
+      <p:sp>
+        <p:nvSpPr>
+          <p:cNvPr id="172" name="TextBox 171"/>
+          <p:cNvSpPr txBox="1"/>
+          <p:nvPr/>
+        </p:nvSpPr>
+        <p:spPr>
+          <a:xfrm>
+            <a:off x="6845655" y="4841748"/>
+            <a:ext cx="4413351" cy="274320"/>
+          </a:xfrm>
+          <a:prstGeom prst="rect">
+            <a:avLst/>
+          </a:prstGeom>
+          <a:noFill/>
+        </p:spPr>
+        <p:txBody>
+          <a:bodyPr wrap="square" lIns="18288" rIns="18288" tIns="9144" bIns="9144" anchor="ctr">
+            <a:spAutoFit/>
+          </a:bodyPr>
+          <a:lstStyle/>
+          <a:p>
+            <a:pPr algn="l"/>
+            <a:r>
+              <a:rPr sz="1150" b="0" i="0">
+                <a:solidFill>
+                  <a:srgbClr val="56616F"/>
+                </a:solidFill>
+                <a:latin typeface="Calibri"/>
+              </a:rPr>
+              <a:t>Historical promo activity calendar</a:t>
+            </a:r>
+          </a:p>
+        </p:txBody>
+      </p:sp>
+      <p:sp>
+        <p:nvSpPr>
+          <p:cNvPr id="173" name="TextBox 172"/>
+          <p:cNvSpPr txBox="1"/>
+          <p:nvPr/>
+        </p:nvSpPr>
+        <p:spPr>
+          <a:xfrm>
+            <a:off x="6607911" y="5138928"/>
+            <a:ext cx="4596231" cy="292608"/>
+          </a:xfrm>
+          <a:prstGeom prst="rect">
+            <a:avLst/>
+          </a:prstGeom>
+          <a:noFill/>
+        </p:spPr>
+        <p:txBody>
+          <a:bodyPr wrap="square" lIns="18288" rIns="18288" tIns="9144" bIns="9144" anchor="ctr">
+            <a:spAutoFit/>
+          </a:bodyPr>
+          <a:lstStyle/>
+          <a:p>
+            <a:pPr algn="l"/>
+            <a:r>
+              <a:rPr sz="1100" b="0" i="1">
+                <a:solidFill>
+                  <a:srgbClr val="8B94A2"/>
+                </a:solidFill>
+                <a:latin typeface="Calibri"/>
+              </a:rPr>
+              <a:t>Taken up separately, after phase 1 goes live.</a:t>
+            </a:r>
+          </a:p>
+        </p:txBody>
+      </p:sp>
+      <p:sp>
+        <p:nvSpPr>
+          <p:cNvPr id="174" name="Rounded Rectangle 173"/>
+          <p:cNvSpPr/>
+          <p:nvPr/>
+        </p:nvSpPr>
+        <p:spPr>
+          <a:xfrm>
+            <a:off x="566928" y="5687568"/>
+            <a:ext cx="11057839" cy="475488"/>
+          </a:xfrm>
+          <a:prstGeom prst="roundRect">
+            <a:avLst>
+              <a:gd name="adj" fmla="val 19230"/>
+            </a:avLst>
+          </a:prstGeom>
+          <a:solidFill>
+            <a:srgbClr val="004C8D"/>
+          </a:solidFill>
+          <a:ln>
+            <a:noFill/>
+          </a:ln>
+          <a:effectLst/>
+        </p:spPr>
+        <p:style>
+          <a:lnRef idx="1">
+            <a:schemeClr val="accent1"/>
+          </a:lnRef>
+          <a:fillRef idx="3">
+            <a:schemeClr val="accent1"/>
+          </a:fillRef>
+          <a:effectRef idx="2">
+            <a:schemeClr val="accent1"/>
+          </a:effectRef>
+          <a:fontRef idx="minor">
+            <a:schemeClr val="lt1"/>
+          </a:fontRef>
+        </p:style>
+        <p:txBody>
+          <a:bodyPr rtlCol="0" anchor="ctr"/>
+          <a:lstStyle/>
+          <a:p>
+            <a:pPr algn="ctr"/>
+          </a:p>
+        </p:txBody>
+      </p:sp>
+      <p:pic>
+        <p:nvPicPr>
+          <p:cNvPr id="175" name="Picture 174" descr="bolt_white.png"/>
+          <p:cNvPicPr>
+            <a:picLocks noChangeAspect="1"/>
+          </p:cNvPicPr>
+          <p:nvPr/>
+        </p:nvPicPr>
+        <p:blipFill>
+          <a:blip r:embed="rId4"/>
+          <a:stretch>
+            <a:fillRect/>
+          </a:stretch>
+        </p:blipFill>
+        <p:spPr>
+          <a:xfrm>
+            <a:off x="877824" y="5824728"/>
+            <a:ext cx="201168" cy="201168"/>
+          </a:xfrm>
+          <a:prstGeom prst="rect">
+            <a:avLst/>
+          </a:prstGeom>
+        </p:spPr>
+      </p:pic>
+      <p:sp>
+        <p:nvSpPr>
+          <p:cNvPr id="176" name="TextBox 175"/>
+          <p:cNvSpPr txBox="1"/>
+          <p:nvPr/>
+        </p:nvSpPr>
+        <p:spPr>
+          <a:xfrm>
+            <a:off x="1225295" y="5687568"/>
+            <a:ext cx="10143439" cy="475488"/>
+          </a:xfrm>
+          <a:prstGeom prst="rect">
+            <a:avLst/>
+          </a:prstGeom>
+          <a:noFill/>
+        </p:spPr>
+        <p:txBody>
+          <a:bodyPr wrap="square" lIns="18288" rIns="18288" tIns="9144" bIns="9144" anchor="ctr">
+            <a:spAutoFit/>
+          </a:bodyPr>
+          <a:lstStyle/>
+          <a:p>
+            <a:pPr algn="l"/>
+            <a:r>
+              <a:rPr sz="1150" b="1" i="0">
+                <a:solidFill>
+                  <a:srgbClr val="FFFFFF"/>
+                </a:solidFill>
+                <a:latin typeface="Calibri"/>
+              </a:rPr>
+              <a:t>Phase 1 — 5,000,000 KZT for a working platform on the client’s own server. Phase 2 is optional and is paid for only if Efes decides to start it.</a:t>
+            </a:r>
+          </a:p>
+        </p:txBody>
+      </p:sp>
+    </p:spTree>
+  </p:cSld>
+  <p:clrMapOvr>
+    <a:masterClrMapping/>
+  </p:clrMapOvr>
+</p:sld>
+</file>
+
 <file path=ppt/slides/slide2.xml><?xml version="1.0" encoding="utf-8"?>
 <p:sld xmlns:a="http://schemas.openxmlformats.org/drawingml/2006/main" xmlns:r="http://schemas.openxmlformats.org/officeDocument/2006/relationships" xmlns:p="http://schemas.openxmlformats.org/presentationml/2006/main">
   <p:cSld name="Slide 7">
@@ -3302,7 +6135,7 @@
                 <a:ea typeface="Calibri" pitchFamily="34" charset="-122"/>
                 <a:cs typeface="Calibri" pitchFamily="34" charset="-120"/>
               </a:rPr>
-              <a:t>Auto-notifying partners by email</a:t>
+              <a:t>Manual email to partners</a:t>
             </a:r>
             <a:endParaRPr lang="en-US" sz="850" dirty="0"/>
           </a:p>
@@ -7040,7 +9873,7 @@
       </p:sp>
       <p:pic>
         <p:nvPicPr>
-          <p:cNvPr id="43" name="video_small.mp4">
+          <p:cNvPr id="43" name="demo-video.mp4">
             <a:hlinkClick r:id="" action="ppaction://media"/>
           </p:cNvPr>
           <p:cNvPicPr>
@@ -7455,11 +10288,11 @@
         <p:spPr>
           <a:xfrm>
             <a:off x="566928" y="2121408"/>
-            <a:ext cx="6400800" cy="3785616"/>
+            <a:ext cx="2627299" cy="1298448"/>
           </a:xfrm>
           <a:prstGeom prst="roundRect">
             <a:avLst>
-              <a:gd name="adj" fmla="val 2173"/>
+              <a:gd name="adj" fmla="val 6338"/>
             </a:avLst>
           </a:prstGeom>
           <a:solidFill>
@@ -7508,14 +10341,14 @@
         </p:nvSpPr>
         <p:spPr>
           <a:xfrm>
-            <a:off x="585216" y="2121408"/>
-            <a:ext cx="6364224" cy="45720"/>
+            <a:off x="566928" y="2139696"/>
+            <a:ext cx="45720" cy="1261872"/>
           </a:xfrm>
           <a:prstGeom prst="rect">
             <a:avLst/>
           </a:prstGeom>
           <a:solidFill>
-            <a:srgbClr val="15924F"/>
+            <a:srgbClr val="004C8D"/>
           </a:solidFill>
           <a:ln>
             <a:noFill/>
@@ -7546,86 +10379,14 @@
       </p:sp>
       <p:sp>
         <p:nvSpPr>
-          <p:cNvPr id="63" name="Rounded Rectangle 62"/>
-          <p:cNvSpPr/>
-          <p:nvPr/>
-        </p:nvSpPr>
-        <p:spPr>
-          <a:xfrm>
-            <a:off x="1024128" y="2578608"/>
-            <a:ext cx="658368" cy="658368"/>
-          </a:xfrm>
-          <a:prstGeom prst="roundRect">
-            <a:avLst>
-              <a:gd name="adj" fmla="val 27777"/>
-            </a:avLst>
-          </a:prstGeom>
-          <a:solidFill>
-            <a:srgbClr val="E7F5EC"/>
-          </a:solidFill>
-          <a:ln w="12700">
-            <a:solidFill>
-              <a:srgbClr val="BBE3C8"/>
-            </a:solidFill>
-          </a:ln>
-          <a:effectLst/>
-        </p:spPr>
-        <p:style>
-          <a:lnRef idx="1">
-            <a:schemeClr val="accent1"/>
-          </a:lnRef>
-          <a:fillRef idx="3">
-            <a:schemeClr val="accent1"/>
-          </a:fillRef>
-          <a:effectRef idx="2">
-            <a:schemeClr val="accent1"/>
-          </a:effectRef>
-          <a:fontRef idx="minor">
-            <a:schemeClr val="lt1"/>
-          </a:fontRef>
-        </p:style>
-        <p:txBody>
-          <a:bodyPr rtlCol="0" anchor="ctr"/>
-          <a:lstStyle/>
-          <a:p>
-            <a:pPr algn="ctr"/>
-          </a:p>
-        </p:txBody>
-      </p:sp>
-      <p:pic>
-        <p:nvPicPr>
-          <p:cNvPr id="64" name="Picture 63" descr="clock_dkgreen.png"/>
-          <p:cNvPicPr>
-            <a:picLocks noChangeAspect="1"/>
-          </p:cNvPicPr>
-          <p:nvPr/>
-        </p:nvPicPr>
-        <p:blipFill>
-          <a:blip r:embed="rId4"/>
-          <a:stretch>
-            <a:fillRect/>
-          </a:stretch>
-        </p:blipFill>
-        <p:spPr>
-          <a:xfrm>
-            <a:off x="1179576" y="2734056"/>
-            <a:ext cx="347472" cy="347472"/>
-          </a:xfrm>
-          <a:prstGeom prst="rect">
-            <a:avLst/>
-          </a:prstGeom>
-        </p:spPr>
-      </p:pic>
-      <p:sp>
-        <p:nvSpPr>
-          <p:cNvPr id="65" name="TextBox 64"/>
+          <p:cNvPr id="63" name="TextBox 62"/>
           <p:cNvSpPr txBox="1"/>
           <p:nvPr/>
         </p:nvSpPr>
         <p:spPr>
           <a:xfrm>
-            <a:off x="1024128" y="3383279"/>
-            <a:ext cx="5486400" cy="1097280"/>
+            <a:off x="841247" y="2258568"/>
+            <a:ext cx="2170099" cy="219456"/>
           </a:xfrm>
           <a:prstGeom prst="rect">
             <a:avLst/>
@@ -7640,27 +10401,27 @@
           <a:p>
             <a:pPr algn="l"/>
             <a:r>
-              <a:rPr sz="6600" b="1" i="0">
-                <a:solidFill>
-                  <a:srgbClr val="15924F"/>
+              <a:rPr sz="850" b="1" i="0" spc="80">
+                <a:solidFill>
+                  <a:srgbClr val="56616F"/>
                 </a:solidFill>
                 <a:latin typeface="Calibri"/>
               </a:rPr>
-              <a:t>158 h/mo</a:t>
-            </a:r>
-          </a:p>
-        </p:txBody>
-      </p:sp>
-      <p:sp>
-        <p:nvSpPr>
-          <p:cNvPr id="66" name="TextBox 65"/>
+              <a:t>PROMOS / YEAR</a:t>
+            </a:r>
+          </a:p>
+        </p:txBody>
+      </p:sp>
+      <p:sp>
+        <p:nvSpPr>
+          <p:cNvPr id="64" name="TextBox 63"/>
           <p:cNvSpPr txBox="1"/>
           <p:nvPr/>
         </p:nvSpPr>
         <p:spPr>
           <a:xfrm>
-            <a:off x="1042416" y="4517136"/>
-            <a:ext cx="5486400" cy="365760"/>
+            <a:off x="841247" y="2523744"/>
+            <a:ext cx="2170099" cy="420624"/>
           </a:xfrm>
           <a:prstGeom prst="rect">
             <a:avLst/>
@@ -7675,119 +10436,27 @@
           <a:p>
             <a:pPr algn="l"/>
             <a:r>
-              <a:rPr sz="1500" b="0" i="0">
-                <a:solidFill>
-                  <a:srgbClr val="56616F"/>
+              <a:rPr sz="2300" b="1" i="0">
+                <a:solidFill>
+                  <a:srgbClr val="004C8D"/>
                 </a:solidFill>
                 <a:latin typeface="Calibri"/>
               </a:rPr>
-              <a:t>of working time returned · Year 1</a:t>
-            </a:r>
-          </a:p>
-        </p:txBody>
-      </p:sp>
-      <p:sp>
-        <p:nvSpPr>
-          <p:cNvPr id="67" name="Rectangle 66"/>
-          <p:cNvSpPr/>
-          <p:nvPr/>
-        </p:nvSpPr>
-        <p:spPr>
-          <a:xfrm>
-            <a:off x="1042416" y="5010912"/>
-            <a:ext cx="5449824" cy="12801"/>
-          </a:xfrm>
-          <a:prstGeom prst="rect">
-            <a:avLst/>
-          </a:prstGeom>
-          <a:solidFill>
-            <a:srgbClr val="E2E7EE"/>
-          </a:solidFill>
-          <a:ln>
-            <a:noFill/>
-          </a:ln>
-          <a:effectLst/>
-        </p:spPr>
-        <p:style>
-          <a:lnRef idx="1">
-            <a:schemeClr val="accent1"/>
-          </a:lnRef>
-          <a:fillRef idx="3">
-            <a:schemeClr val="accent1"/>
-          </a:fillRef>
-          <a:effectRef idx="2">
-            <a:schemeClr val="accent1"/>
-          </a:effectRef>
-          <a:fontRef idx="minor">
-            <a:schemeClr val="lt1"/>
-          </a:fontRef>
-        </p:style>
-        <p:txBody>
-          <a:bodyPr rtlCol="0" anchor="ctr"/>
-          <a:lstStyle/>
-          <a:p>
-            <a:pPr algn="ctr"/>
-          </a:p>
-        </p:txBody>
-      </p:sp>
-      <p:sp>
-        <p:nvSpPr>
-          <p:cNvPr id="68" name="Rounded Rectangle 67"/>
-          <p:cNvSpPr/>
-          <p:nvPr/>
-        </p:nvSpPr>
-        <p:spPr>
-          <a:xfrm>
-            <a:off x="1042416" y="5230368"/>
-            <a:ext cx="2103120" cy="329184"/>
-          </a:xfrm>
-          <a:prstGeom prst="roundRect">
-            <a:avLst>
-              <a:gd name="adj" fmla="val 50000"/>
-            </a:avLst>
-          </a:prstGeom>
-          <a:solidFill>
-            <a:srgbClr val="E7F5EC"/>
-          </a:solidFill>
-          <a:ln w="12700">
-            <a:solidFill>
-              <a:srgbClr val="BBE3C8"/>
-            </a:solidFill>
-          </a:ln>
-          <a:effectLst/>
-        </p:spPr>
-        <p:style>
-          <a:lnRef idx="1">
-            <a:schemeClr val="accent1"/>
-          </a:lnRef>
-          <a:fillRef idx="3">
-            <a:schemeClr val="accent1"/>
-          </a:fillRef>
-          <a:effectRef idx="2">
-            <a:schemeClr val="accent1"/>
-          </a:effectRef>
-          <a:fontRef idx="minor">
-            <a:schemeClr val="lt1"/>
-          </a:fontRef>
-        </p:style>
-        <p:txBody>
-          <a:bodyPr rtlCol="0" anchor="ctr"/>
-          <a:lstStyle/>
-          <a:p>
-            <a:pPr algn="ctr"/>
-          </a:p>
-        </p:txBody>
-      </p:sp>
-      <p:sp>
-        <p:nvSpPr>
-          <p:cNvPr id="69" name="TextBox 68"/>
+              <a:t>×4.6</a:t>
+            </a:r>
+          </a:p>
+        </p:txBody>
+      </p:sp>
+      <p:sp>
+        <p:nvSpPr>
+          <p:cNvPr id="65" name="TextBox 64"/>
           <p:cNvSpPr txBox="1"/>
           <p:nvPr/>
         </p:nvSpPr>
         <p:spPr>
           <a:xfrm>
-            <a:off x="1042416" y="5230368"/>
-            <a:ext cx="2103120" cy="329184"/>
+            <a:off x="841247" y="3008376"/>
+            <a:ext cx="2170099" cy="292608"/>
           </a:xfrm>
           <a:prstGeom prst="rect">
             <a:avLst/>
@@ -7800,33 +10469,42 @@
           </a:bodyPr>
           <a:lstStyle/>
           <a:p>
-            <a:pPr algn="ctr"/>
-            <a:r>
-              <a:rPr sz="1100" b="1" i="0">
+            <a:pPr algn="l"/>
+            <a:r>
+              <a:rPr sz="950" b="0" i="0">
+                <a:solidFill>
+                  <a:srgbClr val="6E7885"/>
+                </a:solidFill>
+                <a:latin typeface="Calibri"/>
+              </a:rPr>
+              <a:t>2,187 → 10,112  </a:t>
+            </a:r>
+            <a:r>
+              <a:rPr sz="950" b="1" i="0">
                 <a:solidFill>
                   <a:srgbClr val="15924F"/>
                 </a:solidFill>
                 <a:latin typeface="Calibri"/>
               </a:rPr>
-              <a:t>28% of routine automated</a:t>
-            </a:r>
-          </a:p>
-        </p:txBody>
-      </p:sp>
-      <p:sp>
-        <p:nvSpPr>
-          <p:cNvPr id="70" name="Rounded Rectangle 69"/>
-          <p:cNvSpPr/>
-          <p:nvPr/>
-        </p:nvSpPr>
-        <p:spPr>
-          <a:xfrm>
-            <a:off x="7132320" y="2121408"/>
-            <a:ext cx="4492447" cy="850392"/>
+              <a:t>+362%</a:t>
+            </a:r>
+          </a:p>
+        </p:txBody>
+      </p:sp>
+      <p:sp>
+        <p:nvSpPr>
+          <p:cNvPr id="66" name="Rounded Rectangle 65"/>
+          <p:cNvSpPr/>
+          <p:nvPr/>
+        </p:nvSpPr>
+        <p:spPr>
+          <a:xfrm>
+            <a:off x="3377107" y="2121408"/>
+            <a:ext cx="2627299" cy="1298448"/>
           </a:xfrm>
           <a:prstGeom prst="roundRect">
             <a:avLst>
-              <a:gd name="adj" fmla="val 9677"/>
+              <a:gd name="adj" fmla="val 6338"/>
             </a:avLst>
           </a:prstGeom>
           <a:solidFill>
@@ -7869,14 +10547,14 @@
       </p:sp>
       <p:sp>
         <p:nvSpPr>
-          <p:cNvPr id="71" name="Rectangle 70"/>
-          <p:cNvSpPr/>
-          <p:nvPr/>
-        </p:nvSpPr>
-        <p:spPr>
-          <a:xfrm>
-            <a:off x="7132320" y="2139696"/>
-            <a:ext cx="45720" cy="813816"/>
+          <p:cNvPr id="67" name="Rectangle 66"/>
+          <p:cNvSpPr/>
+          <p:nvPr/>
+        </p:nvSpPr>
+        <p:spPr>
+          <a:xfrm>
+            <a:off x="3377107" y="2139696"/>
+            <a:ext cx="45720" cy="1261872"/>
           </a:xfrm>
           <a:prstGeom prst="rect">
             <a:avLst/>
@@ -7913,14 +10591,14 @@
       </p:sp>
       <p:sp>
         <p:nvSpPr>
-          <p:cNvPr id="72" name="TextBox 71"/>
+          <p:cNvPr id="68" name="TextBox 67"/>
           <p:cNvSpPr txBox="1"/>
           <p:nvPr/>
         </p:nvSpPr>
         <p:spPr>
           <a:xfrm>
-            <a:off x="7388352" y="2221991"/>
-            <a:ext cx="4035247" cy="201168"/>
+            <a:off x="3651427" y="2258568"/>
+            <a:ext cx="2170099" cy="219456"/>
           </a:xfrm>
           <a:prstGeom prst="rect">
             <a:avLst/>
@@ -7941,21 +10619,21 @@
                 </a:solidFill>
                 <a:latin typeface="Calibri"/>
               </a:rPr>
-              <a:t>PROMOS / YEAR</a:t>
-            </a:r>
-          </a:p>
-        </p:txBody>
-      </p:sp>
-      <p:sp>
-        <p:nvSpPr>
-          <p:cNvPr id="73" name="TextBox 72"/>
+              <a:t>PARTNERS</a:t>
+            </a:r>
+          </a:p>
+        </p:txBody>
+      </p:sp>
+      <p:sp>
+        <p:nvSpPr>
+          <p:cNvPr id="69" name="TextBox 68"/>
           <p:cNvSpPr txBox="1"/>
           <p:nvPr/>
         </p:nvSpPr>
         <p:spPr>
           <a:xfrm>
-            <a:off x="7388352" y="2395727"/>
-            <a:ext cx="2377440" cy="347472"/>
+            <a:off x="3651427" y="2523744"/>
+            <a:ext cx="2170099" cy="420624"/>
           </a:xfrm>
           <a:prstGeom prst="rect">
             <a:avLst/>
@@ -7970,27 +10648,27 @@
           <a:p>
             <a:pPr algn="l"/>
             <a:r>
-              <a:rPr sz="2000" b="1" i="0">
+              <a:rPr sz="2300" b="1" i="0">
                 <a:solidFill>
                   <a:srgbClr val="004C8D"/>
                 </a:solidFill>
                 <a:latin typeface="Calibri"/>
               </a:rPr>
-              <a:t>×4.6</a:t>
-            </a:r>
-          </a:p>
-        </p:txBody>
-      </p:sp>
-      <p:sp>
-        <p:nvSpPr>
-          <p:cNvPr id="74" name="TextBox 73"/>
+              <a:t>33</a:t>
+            </a:r>
+          </a:p>
+        </p:txBody>
+      </p:sp>
+      <p:sp>
+        <p:nvSpPr>
+          <p:cNvPr id="70" name="TextBox 69"/>
           <p:cNvSpPr txBox="1"/>
           <p:nvPr/>
         </p:nvSpPr>
         <p:spPr>
           <a:xfrm>
-            <a:off x="7388352" y="2697479"/>
-            <a:ext cx="4035247" cy="237744"/>
+            <a:off x="3651427" y="3008376"/>
+            <a:ext cx="2170099" cy="292608"/>
           </a:xfrm>
           <a:prstGeom prst="rect">
             <a:avLst/>
@@ -8005,40 +10683,40 @@
           <a:p>
             <a:pPr algn="l"/>
             <a:r>
-              <a:rPr sz="1100" b="0" i="0">
+              <a:rPr sz="950" b="0" i="0">
                 <a:solidFill>
                   <a:srgbClr val="6E7885"/>
                 </a:solidFill>
                 <a:latin typeface="Calibri"/>
               </a:rPr>
-              <a:t>2,187 → 10,112  </a:t>
-            </a:r>
-            <a:r>
-              <a:rPr sz="1100" b="1" i="0">
+              <a:t>31 → 33 · in 6 mo  </a:t>
+            </a:r>
+            <a:r>
+              <a:rPr sz="950" b="1" i="0">
                 <a:solidFill>
                   <a:srgbClr val="15924F"/>
                 </a:solidFill>
                 <a:latin typeface="Calibri"/>
               </a:rPr>
-              <a:t>+362%</a:t>
-            </a:r>
-          </a:p>
-        </p:txBody>
-      </p:sp>
-      <p:sp>
-        <p:nvSpPr>
-          <p:cNvPr id="75" name="Rounded Rectangle 74"/>
-          <p:cNvSpPr/>
-          <p:nvPr/>
-        </p:nvSpPr>
-        <p:spPr>
-          <a:xfrm>
-            <a:off x="7132320" y="3099816"/>
-            <a:ext cx="4492447" cy="850392"/>
+              <a:t>+6.5%</a:t>
+            </a:r>
+          </a:p>
+        </p:txBody>
+      </p:sp>
+      <p:sp>
+        <p:nvSpPr>
+          <p:cNvPr id="71" name="Rounded Rectangle 70"/>
+          <p:cNvSpPr/>
+          <p:nvPr/>
+        </p:nvSpPr>
+        <p:spPr>
+          <a:xfrm>
+            <a:off x="6187287" y="2121408"/>
+            <a:ext cx="2627299" cy="1298448"/>
           </a:xfrm>
           <a:prstGeom prst="roundRect">
             <a:avLst>
-              <a:gd name="adj" fmla="val 9677"/>
+              <a:gd name="adj" fmla="val 6338"/>
             </a:avLst>
           </a:prstGeom>
           <a:solidFill>
@@ -8081,14 +10759,14 @@
       </p:sp>
       <p:sp>
         <p:nvSpPr>
-          <p:cNvPr id="76" name="Rectangle 75"/>
-          <p:cNvSpPr/>
-          <p:nvPr/>
-        </p:nvSpPr>
-        <p:spPr>
-          <a:xfrm>
-            <a:off x="7132320" y="3118104"/>
-            <a:ext cx="45720" cy="813816"/>
+          <p:cNvPr id="72" name="Rectangle 71"/>
+          <p:cNvSpPr/>
+          <p:nvPr/>
+        </p:nvSpPr>
+        <p:spPr>
+          <a:xfrm>
+            <a:off x="6187287" y="2139696"/>
+            <a:ext cx="45720" cy="1261872"/>
           </a:xfrm>
           <a:prstGeom prst="rect">
             <a:avLst/>
@@ -8125,14 +10803,14 @@
       </p:sp>
       <p:sp>
         <p:nvSpPr>
-          <p:cNvPr id="77" name="TextBox 76"/>
+          <p:cNvPr id="73" name="TextBox 72"/>
           <p:cNvSpPr txBox="1"/>
           <p:nvPr/>
         </p:nvSpPr>
         <p:spPr>
           <a:xfrm>
-            <a:off x="7388352" y="3200400"/>
-            <a:ext cx="4035247" cy="201168"/>
+            <a:off x="6461607" y="2258568"/>
+            <a:ext cx="2170099" cy="219456"/>
           </a:xfrm>
           <a:prstGeom prst="rect">
             <a:avLst/>
@@ -8153,21 +10831,21 @@
                 </a:solidFill>
                 <a:latin typeface="Calibri"/>
               </a:rPr>
-              <a:t>PARTNERS</a:t>
-            </a:r>
-          </a:p>
-        </p:txBody>
-      </p:sp>
-      <p:sp>
-        <p:nvSpPr>
-          <p:cNvPr id="78" name="TextBox 77"/>
+              <a:t>PRODUCTS · SKU</a:t>
+            </a:r>
+          </a:p>
+        </p:txBody>
+      </p:sp>
+      <p:sp>
+        <p:nvSpPr>
+          <p:cNvPr id="74" name="TextBox 73"/>
           <p:cNvSpPr txBox="1"/>
           <p:nvPr/>
         </p:nvSpPr>
         <p:spPr>
           <a:xfrm>
-            <a:off x="7388352" y="3374136"/>
-            <a:ext cx="2377440" cy="347472"/>
+            <a:off x="6461607" y="2523744"/>
+            <a:ext cx="2170099" cy="420624"/>
           </a:xfrm>
           <a:prstGeom prst="rect">
             <a:avLst/>
@@ -8182,27 +10860,27 @@
           <a:p>
             <a:pPr algn="l"/>
             <a:r>
-              <a:rPr sz="2000" b="1" i="0">
+              <a:rPr sz="2300" b="1" i="0">
                 <a:solidFill>
                   <a:srgbClr val="004C8D"/>
                 </a:solidFill>
                 <a:latin typeface="Calibri"/>
               </a:rPr>
-              <a:t>33</a:t>
-            </a:r>
-          </a:p>
-        </p:txBody>
-      </p:sp>
-      <p:sp>
-        <p:nvSpPr>
-          <p:cNvPr id="79" name="TextBox 78"/>
+              <a:t>105</a:t>
+            </a:r>
+          </a:p>
+        </p:txBody>
+      </p:sp>
+      <p:sp>
+        <p:nvSpPr>
+          <p:cNvPr id="75" name="TextBox 74"/>
           <p:cNvSpPr txBox="1"/>
           <p:nvPr/>
         </p:nvSpPr>
         <p:spPr>
           <a:xfrm>
-            <a:off x="7388352" y="3675888"/>
-            <a:ext cx="4035247" cy="237744"/>
+            <a:off x="6461607" y="3008376"/>
+            <a:ext cx="2170099" cy="292608"/>
           </a:xfrm>
           <a:prstGeom prst="rect">
             <a:avLst/>
@@ -8217,40 +10895,40 @@
           <a:p>
             <a:pPr algn="l"/>
             <a:r>
-              <a:rPr sz="1100" b="0" i="0">
+              <a:rPr sz="950" b="0" i="0">
                 <a:solidFill>
                   <a:srgbClr val="6E7885"/>
                 </a:solidFill>
                 <a:latin typeface="Calibri"/>
               </a:rPr>
-              <a:t>31 → 33 · in 6 mo  </a:t>
-            </a:r>
-            <a:r>
-              <a:rPr sz="1100" b="1" i="0">
+              <a:t>78 → 105 · in 6 mo  </a:t>
+            </a:r>
+            <a:r>
+              <a:rPr sz="950" b="1" i="0">
                 <a:solidFill>
                   <a:srgbClr val="15924F"/>
                 </a:solidFill>
                 <a:latin typeface="Calibri"/>
               </a:rPr>
-              <a:t>+6.5%</a:t>
-            </a:r>
-          </a:p>
-        </p:txBody>
-      </p:sp>
-      <p:sp>
-        <p:nvSpPr>
-          <p:cNvPr id="80" name="Rounded Rectangle 79"/>
-          <p:cNvSpPr/>
-          <p:nvPr/>
-        </p:nvSpPr>
-        <p:spPr>
-          <a:xfrm>
-            <a:off x="7132320" y="4078224"/>
-            <a:ext cx="4492447" cy="850392"/>
+              <a:t>+35%</a:t>
+            </a:r>
+          </a:p>
+        </p:txBody>
+      </p:sp>
+      <p:sp>
+        <p:nvSpPr>
+          <p:cNvPr id="76" name="Rounded Rectangle 75"/>
+          <p:cNvSpPr/>
+          <p:nvPr/>
+        </p:nvSpPr>
+        <p:spPr>
+          <a:xfrm>
+            <a:off x="8997467" y="2121408"/>
+            <a:ext cx="2627299" cy="1298448"/>
           </a:xfrm>
           <a:prstGeom prst="roundRect">
             <a:avLst>
-              <a:gd name="adj" fmla="val 9677"/>
+              <a:gd name="adj" fmla="val 6338"/>
             </a:avLst>
           </a:prstGeom>
           <a:solidFill>
@@ -8293,14 +10971,14 @@
       </p:sp>
       <p:sp>
         <p:nvSpPr>
-          <p:cNvPr id="81" name="Rectangle 80"/>
-          <p:cNvSpPr/>
-          <p:nvPr/>
-        </p:nvSpPr>
-        <p:spPr>
-          <a:xfrm>
-            <a:off x="7132320" y="4096512"/>
-            <a:ext cx="45720" cy="813816"/>
+          <p:cNvPr id="77" name="Rectangle 76"/>
+          <p:cNvSpPr/>
+          <p:nvPr/>
+        </p:nvSpPr>
+        <p:spPr>
+          <a:xfrm>
+            <a:off x="8997467" y="2139696"/>
+            <a:ext cx="45720" cy="1261872"/>
           </a:xfrm>
           <a:prstGeom prst="rect">
             <a:avLst/>
@@ -8337,14 +11015,14 @@
       </p:sp>
       <p:sp>
         <p:nvSpPr>
-          <p:cNvPr id="82" name="TextBox 81"/>
+          <p:cNvPr id="78" name="TextBox 77"/>
           <p:cNvSpPr txBox="1"/>
           <p:nvPr/>
         </p:nvSpPr>
         <p:spPr>
           <a:xfrm>
-            <a:off x="7388352" y="4178808"/>
-            <a:ext cx="4035247" cy="201168"/>
+            <a:off x="9271787" y="2258568"/>
+            <a:ext cx="2170099" cy="219456"/>
           </a:xfrm>
           <a:prstGeom prst="rect">
             <a:avLst/>
@@ -8365,21 +11043,21 @@
                 </a:solidFill>
                 <a:latin typeface="Calibri"/>
               </a:rPr>
-              <a:t>PRODUCTS · SKU</a:t>
-            </a:r>
-          </a:p>
-        </p:txBody>
-      </p:sp>
-      <p:sp>
-        <p:nvSpPr>
-          <p:cNvPr id="83" name="TextBox 82"/>
+              <a:t>PROMO TOTAL / YEAR</a:t>
+            </a:r>
+          </a:p>
+        </p:txBody>
+      </p:sp>
+      <p:sp>
+        <p:nvSpPr>
+          <p:cNvPr id="79" name="TextBox 78"/>
           <p:cNvSpPr txBox="1"/>
           <p:nvPr/>
         </p:nvSpPr>
         <p:spPr>
           <a:xfrm>
-            <a:off x="7388352" y="4352544"/>
-            <a:ext cx="2377440" cy="347472"/>
+            <a:off x="9271787" y="2523744"/>
+            <a:ext cx="2170099" cy="420624"/>
           </a:xfrm>
           <a:prstGeom prst="rect">
             <a:avLst/>
@@ -8394,27 +11072,27 @@
           <a:p>
             <a:pPr algn="l"/>
             <a:r>
-              <a:rPr sz="2000" b="1" i="0">
+              <a:rPr sz="2300" b="1" i="0">
                 <a:solidFill>
                   <a:srgbClr val="004C8D"/>
                 </a:solidFill>
                 <a:latin typeface="Calibri"/>
               </a:rPr>
-              <a:t>105</a:t>
-            </a:r>
-          </a:p>
-        </p:txBody>
-      </p:sp>
-      <p:sp>
-        <p:nvSpPr>
-          <p:cNvPr id="84" name="TextBox 83"/>
+              <a:t>2.41 bln ₸</a:t>
+            </a:r>
+          </a:p>
+        </p:txBody>
+      </p:sp>
+      <p:sp>
+        <p:nvSpPr>
+          <p:cNvPr id="80" name="TextBox 79"/>
           <p:cNvSpPr txBox="1"/>
           <p:nvPr/>
         </p:nvSpPr>
         <p:spPr>
           <a:xfrm>
-            <a:off x="7388352" y="4654296"/>
-            <a:ext cx="4035247" cy="237744"/>
+            <a:off x="9271787" y="3008376"/>
+            <a:ext cx="2170099" cy="292608"/>
           </a:xfrm>
           <a:prstGeom prst="rect">
             <a:avLst/>
@@ -8429,40 +11107,40 @@
           <a:p>
             <a:pPr algn="l"/>
             <a:r>
-              <a:rPr sz="1100" b="0" i="0">
+              <a:rPr sz="950" b="0" i="0">
                 <a:solidFill>
                   <a:srgbClr val="6E7885"/>
                 </a:solidFill>
                 <a:latin typeface="Calibri"/>
               </a:rPr>
-              <a:t>78 → 105 · in 6 mo  </a:t>
-            </a:r>
-            <a:r>
-              <a:rPr sz="1100" b="1" i="0">
+              <a:t>1.00 → 2.41 · 2023–2025  </a:t>
+            </a:r>
+            <a:r>
+              <a:rPr sz="950" b="1" i="0">
                 <a:solidFill>
                   <a:srgbClr val="15924F"/>
                 </a:solidFill>
                 <a:latin typeface="Calibri"/>
               </a:rPr>
-              <a:t>+35%</a:t>
-            </a:r>
-          </a:p>
-        </p:txBody>
-      </p:sp>
-      <p:sp>
-        <p:nvSpPr>
-          <p:cNvPr id="85" name="Rounded Rectangle 84"/>
-          <p:cNvSpPr/>
-          <p:nvPr/>
-        </p:nvSpPr>
-        <p:spPr>
-          <a:xfrm>
-            <a:off x="7132320" y="5056632"/>
-            <a:ext cx="4492447" cy="850392"/>
+              <a:t>+140%</a:t>
+            </a:r>
+          </a:p>
+        </p:txBody>
+      </p:sp>
+      <p:sp>
+        <p:nvSpPr>
+          <p:cNvPr id="81" name="Rounded Rectangle 80"/>
+          <p:cNvSpPr/>
+          <p:nvPr/>
+        </p:nvSpPr>
+        <p:spPr>
+          <a:xfrm>
+            <a:off x="566928" y="3657600"/>
+            <a:ext cx="11057839" cy="2249424"/>
           </a:xfrm>
           <a:prstGeom prst="roundRect">
             <a:avLst>
-              <a:gd name="adj" fmla="val 9677"/>
+              <a:gd name="adj" fmla="val 3658"/>
             </a:avLst>
           </a:prstGeom>
           <a:solidFill>
@@ -8505,20 +11183,20 @@
       </p:sp>
       <p:sp>
         <p:nvSpPr>
-          <p:cNvPr id="86" name="Rectangle 85"/>
-          <p:cNvSpPr/>
-          <p:nvPr/>
-        </p:nvSpPr>
-        <p:spPr>
-          <a:xfrm>
-            <a:off x="7132320" y="5074920"/>
-            <a:ext cx="45720" cy="813816"/>
+          <p:cNvPr id="82" name="Rectangle 81"/>
+          <p:cNvSpPr/>
+          <p:nvPr/>
+        </p:nvSpPr>
+        <p:spPr>
+          <a:xfrm>
+            <a:off x="585216" y="3657600"/>
+            <a:ext cx="11021263" cy="45720"/>
           </a:xfrm>
           <a:prstGeom prst="rect">
             <a:avLst/>
           </a:prstGeom>
           <a:solidFill>
-            <a:srgbClr val="004C8D"/>
+            <a:srgbClr val="15924F"/>
           </a:solidFill>
           <a:ln>
             <a:noFill/>
@@ -8549,14 +11227,86 @@
       </p:sp>
       <p:sp>
         <p:nvSpPr>
-          <p:cNvPr id="87" name="TextBox 86"/>
+          <p:cNvPr id="83" name="Rounded Rectangle 82"/>
+          <p:cNvSpPr/>
+          <p:nvPr/>
+        </p:nvSpPr>
+        <p:spPr>
+          <a:xfrm>
+            <a:off x="1133856" y="4311396"/>
+            <a:ext cx="749808" cy="749808"/>
+          </a:xfrm>
+          <a:prstGeom prst="roundRect">
+            <a:avLst>
+              <a:gd name="adj" fmla="val 26829"/>
+            </a:avLst>
+          </a:prstGeom>
+          <a:solidFill>
+            <a:srgbClr val="E7F5EC"/>
+          </a:solidFill>
+          <a:ln w="12700">
+            <a:solidFill>
+              <a:srgbClr val="BBE3C8"/>
+            </a:solidFill>
+          </a:ln>
+          <a:effectLst/>
+        </p:spPr>
+        <p:style>
+          <a:lnRef idx="1">
+            <a:schemeClr val="accent1"/>
+          </a:lnRef>
+          <a:fillRef idx="3">
+            <a:schemeClr val="accent1"/>
+          </a:fillRef>
+          <a:effectRef idx="2">
+            <a:schemeClr val="accent1"/>
+          </a:effectRef>
+          <a:fontRef idx="minor">
+            <a:schemeClr val="lt1"/>
+          </a:fontRef>
+        </p:style>
+        <p:txBody>
+          <a:bodyPr rtlCol="0" anchor="ctr"/>
+          <a:lstStyle/>
+          <a:p>
+            <a:pPr algn="ctr"/>
+          </a:p>
+        </p:txBody>
+      </p:sp>
+      <p:pic>
+        <p:nvPicPr>
+          <p:cNvPr id="84" name="Picture 83" descr="clock_dkgreen.png"/>
+          <p:cNvPicPr>
+            <a:picLocks noChangeAspect="1"/>
+          </p:cNvPicPr>
+          <p:nvPr/>
+        </p:nvPicPr>
+        <p:blipFill>
+          <a:blip r:embed="rId4"/>
+          <a:stretch>
+            <a:fillRect/>
+          </a:stretch>
+        </p:blipFill>
+        <p:spPr>
+          <a:xfrm>
+            <a:off x="1316736" y="4494276"/>
+            <a:ext cx="384048" cy="384048"/>
+          </a:xfrm>
+          <a:prstGeom prst="rect">
+            <a:avLst/>
+          </a:prstGeom>
+        </p:spPr>
+      </p:pic>
+      <p:sp>
+        <p:nvSpPr>
+          <p:cNvPr id="85" name="TextBox 84"/>
           <p:cNvSpPr txBox="1"/>
           <p:nvPr/>
         </p:nvSpPr>
         <p:spPr>
           <a:xfrm>
-            <a:off x="7388352" y="5157216"/>
-            <a:ext cx="4035247" cy="201168"/>
+            <a:off x="2157984" y="4160520"/>
+            <a:ext cx="4297680" cy="1051560"/>
           </a:xfrm>
           <a:prstGeom prst="rect">
             <a:avLst/>
@@ -8571,27 +11321,27 @@
           <a:p>
             <a:pPr algn="l"/>
             <a:r>
-              <a:rPr sz="850" b="1" i="0" spc="80">
-                <a:solidFill>
-                  <a:srgbClr val="56616F"/>
+              <a:rPr sz="6200" b="1" i="0">
+                <a:solidFill>
+                  <a:srgbClr val="15924F"/>
                 </a:solidFill>
                 <a:latin typeface="Calibri"/>
               </a:rPr>
-              <a:t>PROMO TOTAL / YEAR</a:t>
-            </a:r>
-          </a:p>
-        </p:txBody>
-      </p:sp>
-      <p:sp>
-        <p:nvSpPr>
-          <p:cNvPr id="88" name="TextBox 87"/>
+              <a:t>158 h/mo</a:t>
+            </a:r>
+          </a:p>
+        </p:txBody>
+      </p:sp>
+      <p:sp>
+        <p:nvSpPr>
+          <p:cNvPr id="86" name="TextBox 85"/>
           <p:cNvSpPr txBox="1"/>
           <p:nvPr/>
         </p:nvSpPr>
         <p:spPr>
           <a:xfrm>
-            <a:off x="7388352" y="5330952"/>
-            <a:ext cx="2377440" cy="347472"/>
+            <a:off x="2194560" y="5230368"/>
+            <a:ext cx="4297680" cy="365760"/>
           </a:xfrm>
           <a:prstGeom prst="rect">
             <a:avLst/>
@@ -8606,14 +11356,106 @@
           <a:p>
             <a:pPr algn="l"/>
             <a:r>
-              <a:rPr sz="2000" b="1" i="0">
-                <a:solidFill>
-                  <a:srgbClr val="004C8D"/>
+              <a:rPr sz="1450" b="0" i="0">
+                <a:solidFill>
+                  <a:srgbClr val="56616F"/>
                 </a:solidFill>
                 <a:latin typeface="Calibri"/>
               </a:rPr>
-              <a:t>2.41 bln ₸</a:t>
-            </a:r>
+              <a:t>of working time returned · Year 1</a:t>
+            </a:r>
+          </a:p>
+        </p:txBody>
+      </p:sp>
+      <p:sp>
+        <p:nvSpPr>
+          <p:cNvPr id="87" name="Rectangle 86"/>
+          <p:cNvSpPr/>
+          <p:nvPr/>
+        </p:nvSpPr>
+        <p:spPr>
+          <a:xfrm>
+            <a:off x="6620256" y="4096512"/>
+            <a:ext cx="12801" cy="1371600"/>
+          </a:xfrm>
+          <a:prstGeom prst="rect">
+            <a:avLst/>
+          </a:prstGeom>
+          <a:solidFill>
+            <a:srgbClr val="E2E7EE"/>
+          </a:solidFill>
+          <a:ln>
+            <a:noFill/>
+          </a:ln>
+          <a:effectLst/>
+        </p:spPr>
+        <p:style>
+          <a:lnRef idx="1">
+            <a:schemeClr val="accent1"/>
+          </a:lnRef>
+          <a:fillRef idx="3">
+            <a:schemeClr val="accent1"/>
+          </a:fillRef>
+          <a:effectRef idx="2">
+            <a:schemeClr val="accent1"/>
+          </a:effectRef>
+          <a:fontRef idx="minor">
+            <a:schemeClr val="lt1"/>
+          </a:fontRef>
+        </p:style>
+        <p:txBody>
+          <a:bodyPr rtlCol="0" anchor="ctr"/>
+          <a:lstStyle/>
+          <a:p>
+            <a:pPr algn="ctr"/>
+          </a:p>
+        </p:txBody>
+      </p:sp>
+      <p:sp>
+        <p:nvSpPr>
+          <p:cNvPr id="88" name="Rounded Rectangle 87"/>
+          <p:cNvSpPr/>
+          <p:nvPr/>
+        </p:nvSpPr>
+        <p:spPr>
+          <a:xfrm>
+            <a:off x="7077456" y="4087368"/>
+            <a:ext cx="2212848" cy="365760"/>
+          </a:xfrm>
+          <a:prstGeom prst="roundRect">
+            <a:avLst>
+              <a:gd name="adj" fmla="val 50000"/>
+            </a:avLst>
+          </a:prstGeom>
+          <a:solidFill>
+            <a:srgbClr val="E7F5EC"/>
+          </a:solidFill>
+          <a:ln w="12700">
+            <a:solidFill>
+              <a:srgbClr val="BBE3C8"/>
+            </a:solidFill>
+          </a:ln>
+          <a:effectLst/>
+        </p:spPr>
+        <p:style>
+          <a:lnRef idx="1">
+            <a:schemeClr val="accent1"/>
+          </a:lnRef>
+          <a:fillRef idx="3">
+            <a:schemeClr val="accent1"/>
+          </a:fillRef>
+          <a:effectRef idx="2">
+            <a:schemeClr val="accent1"/>
+          </a:effectRef>
+          <a:fontRef idx="minor">
+            <a:schemeClr val="lt1"/>
+          </a:fontRef>
+        </p:style>
+        <p:txBody>
+          <a:bodyPr rtlCol="0" anchor="ctr"/>
+          <a:lstStyle/>
+          <a:p>
+            <a:pPr algn="ctr"/>
           </a:p>
         </p:txBody>
       </p:sp>
@@ -8625,8 +11467,8 @@
         </p:nvSpPr>
         <p:spPr>
           <a:xfrm>
-            <a:off x="7388352" y="5632704"/>
-            <a:ext cx="4035247" cy="237744"/>
+            <a:off x="7077456" y="4087368"/>
+            <a:ext cx="2212848" cy="365760"/>
           </a:xfrm>
           <a:prstGeom prst="rect">
             <a:avLst/>
@@ -8639,24 +11481,54 @@
           </a:bodyPr>
           <a:lstStyle/>
           <a:p>
-            <a:pPr algn="l"/>
-            <a:r>
-              <a:rPr sz="1100" b="0" i="0">
-                <a:solidFill>
-                  <a:srgbClr val="6E7885"/>
+            <a:pPr algn="ctr"/>
+            <a:r>
+              <a:rPr sz="1150" b="1" i="0">
+                <a:solidFill>
+                  <a:srgbClr val="15924F"/>
                 </a:solidFill>
                 <a:latin typeface="Calibri"/>
               </a:rPr>
-              <a:t>1.00 → 2.41 · 2023–2025  </a:t>
-            </a:r>
-            <a:r>
-              <a:rPr sz="1100" b="1" i="0">
-                <a:solidFill>
-                  <a:srgbClr val="15924F"/>
+              <a:t>28% of routine automated</a:t>
+            </a:r>
+          </a:p>
+        </p:txBody>
+      </p:sp>
+      <p:sp>
+        <p:nvSpPr>
+          <p:cNvPr id="90" name="TextBox 89"/>
+          <p:cNvSpPr txBox="1"/>
+          <p:nvPr/>
+        </p:nvSpPr>
+        <p:spPr>
+          <a:xfrm>
+            <a:off x="7077456" y="4617720"/>
+            <a:ext cx="4044391" cy="859536"/>
+          </a:xfrm>
+          <a:prstGeom prst="rect">
+            <a:avLst/>
+          </a:prstGeom>
+          <a:noFill/>
+        </p:spPr>
+        <p:txBody>
+          <a:bodyPr wrap="square" lIns="18288" rIns="18288" tIns="9144" bIns="9144" anchor="t">
+            <a:spAutoFit/>
+          </a:bodyPr>
+          <a:lstStyle/>
+          <a:p>
+            <a:pPr algn="l">
+              <a:lnSpc>
+                <a:spcPct val="125000"/>
+              </a:lnSpc>
+            </a:pPr>
+            <a:r>
+              <a:rPr sz="1250" b="0" i="0">
+                <a:solidFill>
+                  <a:srgbClr val="56616F"/>
                 </a:solidFill>
                 <a:latin typeface="Calibri"/>
               </a:rPr>
-              <a:t>+140%</a:t>
+              <a:t>The platform moves data between Excel, Panorama and partner emails by itself. Specialists put that time back into working with partners and checking calculations.</a:t>
             </a:r>
           </a:p>
         </p:txBody>

</xml_diff>